<commit_message>
Add ETL sketch, SQL/Mermaid diagram sources, missingness handling, dbt-marts pitch
- docs/phase2_etl_sketch.md: two-plane ETL design + column→placement map & Quest parser deep-dives
- sql/ and mermaid/ : constraint-free DDL + erDiagram twins of each model for draw.io import;
  sql/v_responses_enriched.sql (analyst convenience view, incl. response_option_set)
- Phase 2: optional gated `session_questions` (per session x placement reach/answer marker) for
  SATA "reached but selected none"; regenerated Model B ERDs + deck
- internal_pitch: curated derived-variable dbt marts section; example_queries: convenience view,
  hierarchy/filter (Q5/Q6) examples
</commit_message>
<xml_diff>
--- a/docs/Connect_Data_Model_Pitch.pptx
+++ b/docs/Connect_Data_Model_Pitch.pptx
@@ -797,7 +797,7 @@
           <a:lstStyle/>
           <a:p>
             <a:r>
-              <a:t>Round hub (~ OMOP visit) off participants; response_sessions = DevOps 'surveys' table; collection/kit/incentive/refusal facts key on (connect_id, round); v_participant_events = SMDB unified view. See data_model_events.dbml.</a:t>
+              <a:t>Round hub (~ OMOP visit) off participants; response_sessions = DevOps 'surveys' table; collection/kit/incentive/refusal facts key on (connect_id, round); v_participant_events = SMDB unified view. See dbml/data_model_events.dbml.</a:t>
             </a:r>
           </a:p>
         </p:txBody>
@@ -4907,8 +4907,8 @@
         </p:blipFill>
         <p:spPr>
           <a:xfrm>
-            <a:off x="2071102" y="1280160"/>
-            <a:ext cx="8049490" cy="5029200"/>
+            <a:off x="2039929" y="1280160"/>
+            <a:ext cx="8111836" cy="5029200"/>
           </a:xfrm>
           <a:prstGeom prst="rect">
             <a:avLst/>

</xml_diff>

<commit_message>
Add value-prop opener, long-format analytics demo slides, and integrated overview
- Deck: new "Why a data model?" value-prop opener (self-describing, no tribal knowledge,
  metadata-in-data, schema contract, shared abstractions); OMOP slide retitled as the build
- Deck: 3 "Analyzing long format" demo slides (labels via one join; wide via a generic
  PIVOT in SQL/Python/R; counts as a GROUP BY) backed by runnable sql/demo_long_format.sql (DuckDB)
- docs/connect_integrated*.svg: overview overlaying the survey-answer plane + event/round plane
  (the responses -> session -> round seam)
</commit_message>
<xml_diff>
--- a/docs/Connect_Data_Model_Pitch.pptx
+++ b/docs/Connect_Data_Model_Pitch.pptx
@@ -21,6 +21,10 @@
     <p:sldId id="269" r:id="rId21"/>
     <p:sldId id="270" r:id="rId22"/>
     <p:sldId id="271" r:id="rId23"/>
+    <p:sldId id="272" r:id="rId24"/>
+    <p:sldId id="273" r:id="rId25"/>
+    <p:sldId id="274" r:id="rId26"/>
+    <p:sldId id="275" r:id="rId27"/>
   </p:sldIdLst>
   <p:sldSz cx="12191695" cy="6858000" type="screen4x3"/>
   <p:notesSz cx="6858000" cy="9144000"/>
@@ -587,7 +591,7 @@
           <a:lstStyle/>
           <a:p>
             <a:r>
-              <a:t>Full Phase 2 ERD. Dense by design — the SVG (docs/connect_data_model.svg) zooms cleanly. See internal_pitch.md — Phase 2.</a:t>
+              <a:t>Phase 2 adds the placement bridge, sessions, version-scoped options, layers, governance. See internal_pitch.md — Phase 1 / Phase 2.</a:t>
             </a:r>
           </a:p>
         </p:txBody>
@@ -657,7 +661,7 @@
           <a:lstStyle/>
           <a:p>
             <a:r>
-              <a:t>Verdict: doable, nothing needs a capability Connect lacks — but it's dependencies + org/policy, not modeling. CIDTool verified 2026-06-22 as a small in-dev JS tool, not a production dimension emitter. Sequence: dims+placement+sessions first (mechanical); governance in parallel early (long pole, gates external release); concept plane/marts/OMOP deferred until pulled. BigQuery has no FK enforcement — relationships logical, enforced by transform + dbt tests. See CLAUDE.md — Phase 2 feasibility.</a:t>
+              <a:t>Full Phase 2 ERD. Dense by design — the SVG (docs/connect_data_model.svg) zooms cleanly. See internal_pitch.md — Phase 2.</a:t>
             </a:r>
           </a:p>
         </p:txBody>
@@ -727,7 +731,7 @@
           <a:lstStyle/>
           <a:p>
             <a:r>
-              <a:t>Same long-format thesis as our model, arrived at independently. The one fix: concept IDs, not strings. See CLAUDE.md — Event plane: DevOps long-format proposal; docs/devops_event_tables_memo.md.</a:t>
+              <a:t>Verdict: doable, nothing needs a capability Connect lacks — but it's dependencies + org/policy, not modeling. CIDTool verified 2026-06-22 as a small in-dev JS tool, not a production dimension emitter. Sequence: dims+placement+sessions first (mechanical); governance in parallel early (long pole, gates external release); concept plane/marts/OMOP deferred until pulled. BigQuery has no FK enforcement — relationships logical, enforced by transform + dbt tests. See CLAUDE.md — Phase 2 feasibility.</a:t>
             </a:r>
           </a:p>
         </p:txBody>
@@ -797,7 +801,7 @@
           <a:lstStyle/>
           <a:p>
             <a:r>
-              <a:t>Round hub (~ OMOP visit) off participants; response_sessions = DevOps 'surveys' table; collection/kit/incentive/refusal facts key on (connect_id, round); v_participant_events = SMDB unified view. See dbml/data_model_events.dbml.</a:t>
+              <a:t>Same long-format thesis as our model, arrived at independently. The one fix: concept IDs, not strings. See CLAUDE.md — Event plane: DevOps long-format proposal; docs/devops_event_tables_memo.md.</a:t>
             </a:r>
           </a:p>
         </p:txBody>
@@ -867,7 +871,7 @@
           <a:lstStyle/>
           <a:p>
             <a:r>
-              <a:t>This is the Marts layer (Phase 2, downstream of Core via dbt). Pitch = highest-value case of the OMOP 'write analytics once' thesis: derived variables defined once, canonically, with lineage — vs. re-coded per study (the 3 pain repos). dbt features map to our principles: dbt docs DAG = lineage to source (#12); SQL is the definition (no black box, #12); source()/ref()+access enforce Core→Analytic→Marts (#8); tests move much of the 7,025-rule QC into CI; sensitivity_tier flows via meta, enforced in IAM (#11); model versions/exposures = a derived-variable catalog. Recommend one mart PER construct (grouped), not a wide mega-table. Grain: participant, or participant×wave for longitudinal. Examples map to established cancer-prevention exposure domains (WCRF/AICR). See CLAUDE.md — Derived variables, lineage &amp; dbt / Mart catalog.</a:t>
+              <a:t>Round hub (~ OMOP visit) off participants; response_sessions = DevOps 'surveys' table; collection/kit/incentive/refusal facts key on (connect_id, round); v_participant_events = SMDB unified view. See dbml/data_model_events.dbml.</a:t>
             </a:r>
           </a:p>
         </p:txBody>
@@ -937,7 +941,7 @@
           <a:lstStyle/>
           <a:p>
             <a:r>
-              <a:t>Worked SQL for each row is in internal_pitch.md — Value proposition (Q1–Q5).</a:t>
+              <a:t>This is the Marts layer (Phase 2, downstream of Core via dbt). Pitch = highest-value case of the OMOP 'write analytics once' thesis: derived variables defined once, canonically, with lineage — vs. re-coded per study (the 3 pain repos). dbt features map to our principles: dbt docs DAG = lineage to source (#12); SQL is the definition (no black box, #12); source()/ref()+access enforce Core→Analytic→Marts (#8); tests move much of the 7,025-rule QC into CI; sensitivity_tier flows via meta, enforced in IAM (#11); model versions/exposures = a derived-variable catalog. Recommend one mart PER construct (grouped), not a wide mega-table. Grain: participant, or participant×wave for longitudinal. Examples map to established cancer-prevention exposure domains (WCRF/AICR). See CLAUDE.md — Derived variables, lineage &amp; dbt / Mart catalog.</a:t>
             </a:r>
           </a:p>
         </p:txBody>
@@ -1007,7 +1011,217 @@
           <a:lstStyle/>
           <a:p>
             <a:r>
-              <a:t>Ask: approve Phase 1 now; commit Phase 2 (esp. governance); consider pulling the concept-equivalence plane forward (geocoding). See internal_pitch.md — Recommendation.</a:t>
+              <a:t>Worked SQL for each row is in internal_pitch.md — Value proposition (Q1–Q5).</a:t>
+            </a:r>
+          </a:p>
+        </p:txBody>
+      </p:sp>
+      <p:sp>
+        <p:nvSpPr>
+          <p:cNvPr id="4" name="Slide Number Placeholder 3"/>
+          <p:cNvSpPr>
+            <a:spLocks noGrp="1"/>
+          </p:cNvSpPr>
+          <p:nvPr>
+            <p:ph type="sldNum" idx="5" sz="quarter"/>
+          </p:nvPr>
+        </p:nvSpPr>
+        <p:spPr/>
+      </p:sp>
+    </p:spTree>
+  </p:cSld>
+  <p:clrMapOvr>
+    <a:masterClrMapping/>
+  </p:clrMapOvr>
+</p:notes>
+</file>
+
+<file path=ppt/notesSlides/notesSlide17.xml><?xml version="1.0" encoding="utf-8"?>
+<p:notes xmlns:a="http://schemas.openxmlformats.org/drawingml/2006/main" xmlns:p="http://schemas.openxmlformats.org/presentationml/2006/main" xmlns:r="http://schemas.openxmlformats.org/officeDocument/2006/relationships">
+  <p:cSld>
+    <p:spTree>
+      <p:nvGrpSpPr>
+        <p:cNvPr id="1" name=""/>
+        <p:cNvGrpSpPr/>
+        <p:nvPr/>
+      </p:nvGrpSpPr>
+      <p:grpSpPr>
+        <a:xfrm>
+          <a:off x="0" y="0"/>
+          <a:ext cx="0" cy="0"/>
+          <a:chOff x="0" y="0"/>
+          <a:chExt cx="0" cy="0"/>
+        </a:xfrm>
+      </p:grpSpPr>
+      <p:sp>
+        <p:nvSpPr>
+          <p:cNvPr id="2" name="Slide Image Placeholder 1"/>
+          <p:cNvSpPr>
+            <a:spLocks noGrp="1"/>
+          </p:cNvSpPr>
+          <p:nvPr>
+            <p:ph type="sldImg" idx="2"/>
+          </p:nvPr>
+        </p:nvSpPr>
+        <p:spPr/>
+      </p:sp>
+      <p:sp>
+        <p:nvSpPr>
+          <p:cNvPr id="3" name="Notes Placeholder 2"/>
+          <p:cNvSpPr>
+            <a:spLocks noGrp="1"/>
+          </p:cNvSpPr>
+          <p:nvPr>
+            <p:ph type="body" idx="3" sz="quarter"/>
+          </p:nvPr>
+        </p:nvSpPr>
+        <p:spPr/>
+        <p:txBody>
+          <a:bodyPr/>
+          <a:lstStyle/>
+          <a:p>
+            <a:r>
+              <a:t>Demo data is synthetic (sql/demo_long_format.sql, runs in DuckDB ~ BigQuery). The labels come from joining the dictionary; analysts never memorize concept ids. v_long packages this join so it's literally SELECT * FROM v_long.</a:t>
+            </a:r>
+          </a:p>
+        </p:txBody>
+      </p:sp>
+      <p:sp>
+        <p:nvSpPr>
+          <p:cNvPr id="4" name="Slide Number Placeholder 3"/>
+          <p:cNvSpPr>
+            <a:spLocks noGrp="1"/>
+          </p:cNvSpPr>
+          <p:nvPr>
+            <p:ph type="sldNum" idx="5" sz="quarter"/>
+          </p:nvPr>
+        </p:nvSpPr>
+        <p:spPr/>
+      </p:sp>
+    </p:spTree>
+  </p:cSld>
+  <p:clrMapOvr>
+    <a:masterClrMapping/>
+  </p:clrMapOvr>
+</p:notes>
+</file>
+
+<file path=ppt/notesSlides/notesSlide18.xml><?xml version="1.0" encoding="utf-8"?>
+<p:notes xmlns:a="http://schemas.openxmlformats.org/drawingml/2006/main" xmlns:p="http://schemas.openxmlformats.org/presentationml/2006/main" xmlns:r="http://schemas.openxmlformats.org/officeDocument/2006/relationships">
+  <p:cSld>
+    <p:spTree>
+      <p:nvGrpSpPr>
+        <p:cNvPr id="1" name=""/>
+        <p:cNvGrpSpPr/>
+        <p:nvPr/>
+      </p:nvGrpSpPr>
+      <p:grpSpPr>
+        <a:xfrm>
+          <a:off x="0" y="0"/>
+          <a:ext cx="0" cy="0"/>
+          <a:chOff x="0" y="0"/>
+          <a:chExt cx="0" cy="0"/>
+        </a:xfrm>
+      </p:grpSpPr>
+      <p:sp>
+        <p:nvSpPr>
+          <p:cNvPr id="2" name="Slide Image Placeholder 1"/>
+          <p:cNvSpPr>
+            <a:spLocks noGrp="1"/>
+          </p:cNvSpPr>
+          <p:nvPr>
+            <p:ph type="sldImg" idx="2"/>
+          </p:nvPr>
+        </p:nvSpPr>
+        <p:spPr/>
+      </p:sp>
+      <p:sp>
+        <p:nvSpPr>
+          <p:cNvPr id="3" name="Notes Placeholder 2"/>
+          <p:cNvSpPr>
+            <a:spLocks noGrp="1"/>
+          </p:cNvSpPr>
+          <p:nvPr>
+            <p:ph type="body" idx="3" sz="quarter"/>
+          </p:nvPr>
+        </p:nvSpPr>
+        <p:spPr/>
+        <p:txBody>
+          <a:bodyPr/>
+          <a:lstStyle/>
+          <a:p>
+            <a:r>
+              <a:t>Reframed: the pivot is GENERIC and metadata-driven — no hardcoded column list (the opposite of a wide-table script). NOTE on completeness: DuckDB's PIVOT implicitly groups by every column not in ON/USING, so you must project to (id, name, value) first — that's the subquery shown; this exact statement runs. The fully-dynamic ON…USING form is DuckDB; BigQuery's PIVOT needs the value list (FOR question_text IN (...)) or dynamic SQL. pandas.pivot and tidyr::pivot_wider are fully dynamic and are what analysts already use. All three verified against sql/demo_long_format.sql (synthetic). Select-all is excluded (multi-valued → belongs in long, next slide). Parameterize by survey → a reusable get_wide() helper (tool built on the contract).</a:t>
+            </a:r>
+          </a:p>
+        </p:txBody>
+      </p:sp>
+      <p:sp>
+        <p:nvSpPr>
+          <p:cNvPr id="4" name="Slide Number Placeholder 3"/>
+          <p:cNvSpPr>
+            <a:spLocks noGrp="1"/>
+          </p:cNvSpPr>
+          <p:nvPr>
+            <p:ph type="sldNum" idx="5" sz="quarter"/>
+          </p:nvPr>
+        </p:nvSpPr>
+        <p:spPr/>
+      </p:sp>
+    </p:spTree>
+  </p:cSld>
+  <p:clrMapOvr>
+    <a:masterClrMapping/>
+  </p:clrMapOvr>
+</p:notes>
+</file>
+
+<file path=ppt/notesSlides/notesSlide19.xml><?xml version="1.0" encoding="utf-8"?>
+<p:notes xmlns:a="http://schemas.openxmlformats.org/drawingml/2006/main" xmlns:p="http://schemas.openxmlformats.org/presentationml/2006/main" xmlns:r="http://schemas.openxmlformats.org/officeDocument/2006/relationships">
+  <p:cSld>
+    <p:spTree>
+      <p:nvGrpSpPr>
+        <p:cNvPr id="1" name=""/>
+        <p:cNvGrpSpPr/>
+        <p:nvPr/>
+      </p:nvGrpSpPr>
+      <p:grpSpPr>
+        <a:xfrm>
+          <a:off x="0" y="0"/>
+          <a:ext cx="0" cy="0"/>
+          <a:chOff x="0" y="0"/>
+          <a:chExt cx="0" cy="0"/>
+        </a:xfrm>
+      </p:grpSpPr>
+      <p:sp>
+        <p:nvSpPr>
+          <p:cNvPr id="2" name="Slide Image Placeholder 1"/>
+          <p:cNvSpPr>
+            <a:spLocks noGrp="1"/>
+          </p:cNvSpPr>
+          <p:nvPr>
+            <p:ph type="sldImg" idx="2"/>
+          </p:nvPr>
+        </p:nvSpPr>
+        <p:spPr/>
+      </p:sp>
+      <p:sp>
+        <p:nvSpPr>
+          <p:cNvPr id="3" name="Notes Placeholder 2"/>
+          <p:cNvSpPr>
+            <a:spLocks noGrp="1"/>
+          </p:cNvSpPr>
+          <p:nvPr>
+            <p:ph type="body" idx="3" sz="quarter"/>
+          </p:nvPr>
+        </p:nvSpPr>
+        <p:spPr/>
+        <p:txBody>
+          <a:bodyPr/>
+          <a:lstStyle/>
+          <a:p>
+            <a:r>
+              <a:t>Counts are GROUP BY — often simpler than wide. Select-all is the standout: wide makes you know and sum a changing set of indicator columns; long is one group-by on response_label. Same query shape works for every question by swapping the concept id (e.g. Smoking Status -&gt; Never 2 / Former 2 / Current 1).</a:t>
             </a:r>
           </a:p>
         </p:txBody>
@@ -1077,7 +1291,77 @@
           <a:lstStyle/>
           <a:p>
             <a:r>
-              <a:t>Lead with the OMOP principle the team already accepts. See internal_pitch.md — Why a data model at all?</a:t>
+              <a:t>The opener: why model at all. Six plain-English value props — self-describing; queryable without tribal knowledge; metadata in the data (not sidecar files); standardized analyses; a schema contract tools can build on (and survive new data); shared abstractions (all select-all handled one way, all loops one way). Sets up the next slide: this is exactly the OMOP lesson. See internal_pitch.md — Why a data model at all?</a:t>
+            </a:r>
+          </a:p>
+        </p:txBody>
+      </p:sp>
+      <p:sp>
+        <p:nvSpPr>
+          <p:cNvPr id="4" name="Slide Number Placeholder 3"/>
+          <p:cNvSpPr>
+            <a:spLocks noGrp="1"/>
+          </p:cNvSpPr>
+          <p:nvPr>
+            <p:ph type="sldNum" idx="5" sz="quarter"/>
+          </p:nvPr>
+        </p:nvSpPr>
+        <p:spPr/>
+      </p:sp>
+    </p:spTree>
+  </p:cSld>
+  <p:clrMapOvr>
+    <a:masterClrMapping/>
+  </p:clrMapOvr>
+</p:notes>
+</file>
+
+<file path=ppt/notesSlides/notesSlide20.xml><?xml version="1.0" encoding="utf-8"?>
+<p:notes xmlns:a="http://schemas.openxmlformats.org/drawingml/2006/main" xmlns:p="http://schemas.openxmlformats.org/presentationml/2006/main" xmlns:r="http://schemas.openxmlformats.org/officeDocument/2006/relationships">
+  <p:cSld>
+    <p:spTree>
+      <p:nvGrpSpPr>
+        <p:cNvPr id="1" name=""/>
+        <p:cNvGrpSpPr/>
+        <p:nvPr/>
+      </p:nvGrpSpPr>
+      <p:grpSpPr>
+        <a:xfrm>
+          <a:off x="0" y="0"/>
+          <a:ext cx="0" cy="0"/>
+          <a:chOff x="0" y="0"/>
+          <a:chExt cx="0" cy="0"/>
+        </a:xfrm>
+      </p:grpSpPr>
+      <p:sp>
+        <p:nvSpPr>
+          <p:cNvPr id="2" name="Slide Image Placeholder 1"/>
+          <p:cNvSpPr>
+            <a:spLocks noGrp="1"/>
+          </p:cNvSpPr>
+          <p:nvPr>
+            <p:ph type="sldImg" idx="2"/>
+          </p:nvPr>
+        </p:nvSpPr>
+        <p:spPr/>
+      </p:sp>
+      <p:sp>
+        <p:nvSpPr>
+          <p:cNvPr id="3" name="Notes Placeholder 2"/>
+          <p:cNvSpPr>
+            <a:spLocks noGrp="1"/>
+          </p:cNvSpPr>
+          <p:nvPr>
+            <p:ph type="body" idx="3" sz="quarter"/>
+          </p:nvPr>
+        </p:nvSpPr>
+        <p:spPr/>
+        <p:txBody>
+          <a:bodyPr/>
+          <a:lstStyle/>
+          <a:p>
+            <a:r>
+              <a:t>Ask: approve Phase 1 now; commit Phase 2 (esp. governance); consider pulling the concept-equivalence plane forward (geocoding). See internal_pitch.md — Recommendation.</a:t>
             </a:r>
           </a:p>
         </p:txBody>
@@ -1147,7 +1431,7 @@
           <a:lstStyle/>
           <a:p>
             <a:r>
-              <a:t>The five pains. Punchline lands after the exhibits. See internal_pitch.md — Why — the problems we all live with.</a:t>
+              <a:t>Lead with the OMOP principle the team already accepts. See internal_pitch.md — Why a data model at all?</a:t>
             </a:r>
           </a:p>
         </p:txBody>
@@ -1217,7 +1501,7 @@
           <a:lstStyle/>
           <a:p>
             <a:r>
-              <a:t>A colleague's flagship report — evidence, not criticism. See internal_pitch.md — This isn't hypothetical.</a:t>
+              <a:t>The five pains. Punchline lands after the exhibits. See internal_pitch.md — Why — the problems we all live with.</a:t>
             </a:r>
           </a:p>
         </p:txBody>
@@ -1287,7 +1571,7 @@
           <a:lstStyle/>
           <a:p>
             <a:r>
-              <a:t>Recalibrated: ~35% directly generatable (value/type/length); a further ~50% skip-gated -&gt; becomes shared skip-logic data authored ONCE instead of re-coded across 3 repos (simple majority machine-generated, ~8% complex tail like percentDiff preserved as raw expression). ~15% genuinely custom. Contingent on the richer (QuickQ) skip_rule representation. Module 4 ~50% custom is the honest counter-case. See internal_pitch.md — QA/QC engine; CLAUDE.md — Skip-logic complexity &amp; coverage.</a:t>
+              <a:t>A colleague's flagship report — evidence, not criticism. See internal_pitch.md — This isn't hypothetical.</a:t>
             </a:r>
           </a:p>
         </p:txBody>
@@ -1357,7 +1641,7 @@
           <a:lstStyle/>
           <a:p>
             <a:r>
-              <a:t>Strongest case for the concept-equivalence plane; sits beyond Phase 2's first cut — argues to pull it forward. See internal_pitch.md — geocoding.</a:t>
+              <a:t>Recalibrated: ~35% directly generatable (value/type/length); a further ~50% skip-gated -&gt; becomes shared skip-logic data authored ONCE instead of re-coded across 3 repos (simple majority machine-generated, ~8% complex tail like percentDiff preserved as raw expression). ~15% genuinely custom. Contingent on the richer (QuickQ) skip_rule representation. Module 4 ~50% custom is the honest counter-case. See internal_pitch.md — QA/QC engine; CLAUDE.md — Skip-logic complexity &amp; coverage.</a:t>
             </a:r>
           </a:p>
         </p:txBody>
@@ -1427,7 +1711,7 @@
           <a:lstStyle/>
           <a:p>
             <a:r>
-              <a:t>Phase 1 model: CIDTool dictionary as-is + one responses fact. Same thesis carries to Phase 2. See internal_pitch.md — The idea / Phase 1.</a:t>
+              <a:t>Strongest case for the concept-equivalence plane; sits beyond Phase 2's first cut — argues to pull it forward. See internal_pitch.md — geocoding.</a:t>
             </a:r>
           </a:p>
         </p:txBody>
@@ -1497,7 +1781,7 @@
           <a:lstStyle/>
           <a:p>
             <a:r>
-              <a:t>EASE-IN framing for a skeptical audience. The current encoding isn't wrong — it faithfully mirrors physical storage (a multi-select really is N 0/1 columns). The model's improvement is logical: an option is an answer choice, not a question, so it belongs in response_options; 'selected' becomes the presence of a row instead of a synthetic Yes/No. Same tooth-loss example as the docs (899251483; options 812107266 accident / 452438775 decay / 886864375 other / 551489317 none; Yes/No = 353358909/104430631). Quest disambiguates select-all [ ] vs single-select ( ) vs grid |grid|. Nothing is thrown away; the dictionary remains the source of truth and this view sits on top. See CLAUDE.md — Source Question is overloaded.</a:t>
+              <a:t>Phase 1 model: CIDTool dictionary as-is + one responses fact. Same thesis carries to Phase 2. See internal_pitch.md — The idea / Phase 1.</a:t>
             </a:r>
           </a:p>
         </p:txBody>
@@ -1567,7 +1851,7 @@
           <a:lstStyle/>
           <a:p>
             <a:r>
-              <a:t>Phase 2 adds the placement bridge, sessions, version-scoped options, layers, governance. See internal_pitch.md — Phase 1 / Phase 2.</a:t>
+              <a:t>EASE-IN framing for a skeptical audience. The current encoding isn't wrong — it faithfully mirrors physical storage (a multi-select really is N 0/1 columns). The model's improvement is logical: an option is an answer choice, not a question, so it belongs in response_options; 'selected' becomes the presence of a row instead of a synthetic Yes/No. Same tooth-loss example as the docs (899251483; options 812107266 accident / 452438775 decay / 886864375 other / 551489317 none; Yes/No = 353358909/104430631). Quest disambiguates select-all [ ] vs single-select ( ) vs grid |grid|. Nothing is thrown away; the dictionary remains the source of truth and this view sits on top. See CLAUDE.md — Source Question is overloaded.</a:t>
             </a:r>
           </a:p>
         </p:txBody>
@@ -4832,6 +5116,533 @@
                 </a:solidFill>
                 <a:latin typeface="Calibri"/>
               </a:rPr>
+              <a:t>A two-phase path</a:t>
+            </a:r>
+          </a:p>
+          <a:p>
+            <a:r>
+              <a:rPr sz="1300" i="1">
+                <a:solidFill>
+                  <a:srgbClr val="BBD5D7"/>
+                </a:solidFill>
+              </a:rPr>
+              <a:t>Phase 1 proves it cheaply · Phase 2 builds the governed warehouse</a:t>
+            </a:r>
+          </a:p>
+        </p:txBody>
+      </p:sp>
+      <p:sp>
+        <p:nvSpPr>
+          <p:cNvPr id="3" name="Rectangle 2"/>
+          <p:cNvSpPr/>
+          <p:nvPr/>
+        </p:nvSpPr>
+        <p:spPr>
+          <a:xfrm>
+            <a:off x="0" y="1051560"/>
+            <a:ext cx="12191695" cy="54864"/>
+          </a:xfrm>
+          <a:prstGeom prst="rect">
+            <a:avLst/>
+          </a:prstGeom>
+          <a:solidFill>
+            <a:srgbClr val="2E8B8B"/>
+          </a:solidFill>
+          <a:ln>
+            <a:noFill/>
+          </a:ln>
+          <a:effectLst/>
+        </p:spPr>
+        <p:style>
+          <a:lnRef idx="1">
+            <a:schemeClr val="accent1"/>
+          </a:lnRef>
+          <a:fillRef idx="3">
+            <a:schemeClr val="accent1"/>
+          </a:fillRef>
+          <a:effectRef idx="2">
+            <a:schemeClr val="accent1"/>
+          </a:effectRef>
+          <a:fontRef idx="minor">
+            <a:schemeClr val="lt1"/>
+          </a:fontRef>
+        </p:style>
+        <p:txBody>
+          <a:bodyPr rtlCol="0" anchor="ctr"/>
+          <a:lstStyle/>
+          <a:p>
+            <a:pPr algn="ctr"/>
+          </a:p>
+        </p:txBody>
+      </p:sp>
+      <p:graphicFrame>
+        <p:nvGraphicFramePr>
+          <p:cNvPr id="4" name="Table 3"/>
+          <p:cNvGraphicFramePr>
+            <a:graphicFrameLocks noGrp="1"/>
+          </p:cNvGraphicFramePr>
+          <p:nvPr/>
+        </p:nvGraphicFramePr>
+        <p:xfrm>
+          <a:off x="548640" y="1554480"/>
+          <a:ext cx="11064240" cy="3108960"/>
+        </p:xfrm>
+        <a:graphic>
+          <a:graphicData uri="http://schemas.openxmlformats.org/drawingml/2006/table">
+            <a:tbl>
+              <a:tblPr firstRow="1" bandRow="1">
+                <a:tableStyleId>{5C22544A-7EE6-4342-B048-85BDC9FD1C3A}</a:tableStyleId>
+              </a:tblPr>
+              <a:tblGrid>
+                <a:gridCol w="1554480"/>
+                <a:gridCol w="4754880"/>
+                <a:gridCol w="4754880"/>
+              </a:tblGrid>
+              <a:tr h="621792">
+                <a:tc>
+                  <a:txBody>
+                    <a:bodyPr wrap="square"/>
+                    <a:lstStyle/>
+                    <a:p>
+                      <a:r>
+                        <a:rPr b="1" sz="1400">
+                          <a:solidFill>
+                            <a:srgbClr val="FFFFFF"/>
+                          </a:solidFill>
+                          <a:latin typeface="Calibri"/>
+                        </a:rPr>
+                        <a:t/>
+                      </a:r>
+                    </a:p>
+                  </a:txBody>
+                  <a:tcPr marL="73152" marR="73152" marT="27432" marB="27432" anchor="ctr">
+                    <a:solidFill>
+                      <a:srgbClr val="16324F"/>
+                    </a:solidFill>
+                  </a:tcPr>
+                </a:tc>
+                <a:tc>
+                  <a:txBody>
+                    <a:bodyPr wrap="square"/>
+                    <a:lstStyle/>
+                    <a:p>
+                      <a:r>
+                        <a:rPr b="1" sz="1400">
+                          <a:solidFill>
+                            <a:srgbClr val="FFFFFF"/>
+                          </a:solidFill>
+                          <a:latin typeface="Calibri"/>
+                        </a:rPr>
+                        <a:t>Phase 1 — Dictionary-Direct</a:t>
+                      </a:r>
+                    </a:p>
+                  </a:txBody>
+                  <a:tcPr marL="73152" marR="73152" marT="27432" marB="27432" anchor="ctr">
+                    <a:solidFill>
+                      <a:srgbClr val="16324F"/>
+                    </a:solidFill>
+                  </a:tcPr>
+                </a:tc>
+                <a:tc>
+                  <a:txBody>
+                    <a:bodyPr wrap="square"/>
+                    <a:lstStyle/>
+                    <a:p>
+                      <a:r>
+                        <a:rPr b="1" sz="1400">
+                          <a:solidFill>
+                            <a:srgbClr val="FFFFFF"/>
+                          </a:solidFill>
+                          <a:latin typeface="Calibri"/>
+                        </a:rPr>
+                        <a:t>Phase 2 — PR2 warehouse</a:t>
+                      </a:r>
+                    </a:p>
+                  </a:txBody>
+                  <a:tcPr marL="73152" marR="73152" marT="27432" marB="27432" anchor="ctr">
+                    <a:solidFill>
+                      <a:srgbClr val="16324F"/>
+                    </a:solidFill>
+                  </a:tcPr>
+                </a:tc>
+              </a:tr>
+              <a:tr h="621792">
+                <a:tc>
+                  <a:txBody>
+                    <a:bodyPr wrap="square"/>
+                    <a:lstStyle/>
+                    <a:p>
+                      <a:r>
+                        <a:rPr sz="1400" b="1">
+                          <a:solidFill>
+                            <a:srgbClr val="222A33"/>
+                          </a:solidFill>
+                          <a:latin typeface="Calibri"/>
+                        </a:rPr>
+                        <a:t>What</a:t>
+                      </a:r>
+                    </a:p>
+                  </a:txBody>
+                  <a:tcPr marL="73152" marR="73152" marT="27432" marB="27432" anchor="ctr">
+                    <a:solidFill>
+                      <a:srgbClr val="FFFFFF"/>
+                    </a:solidFill>
+                  </a:tcPr>
+                </a:tc>
+                <a:tc>
+                  <a:txBody>
+                    <a:bodyPr wrap="square"/>
+                    <a:lstStyle/>
+                    <a:p>
+                      <a:r>
+                        <a:rPr sz="1400">
+                          <a:solidFill>
+                            <a:srgbClr val="222A33"/>
+                          </a:solidFill>
+                          <a:latin typeface="Calibri"/>
+                        </a:rPr>
+                        <a:t>dictionary as-is + 1 responses table</a:t>
+                      </a:r>
+                    </a:p>
+                  </a:txBody>
+                  <a:tcPr marL="73152" marR="73152" marT="27432" marB="27432" anchor="ctr">
+                    <a:solidFill>
+                      <a:srgbClr val="FFFFFF"/>
+                    </a:solidFill>
+                  </a:tcPr>
+                </a:tc>
+                <a:tc>
+                  <a:txBody>
+                    <a:bodyPr wrap="square"/>
+                    <a:lstStyle/>
+                    <a:p>
+                      <a:r>
+                        <a:rPr sz="1400">
+                          <a:solidFill>
+                            <a:srgbClr val="222A33"/>
+                          </a:solidFill>
+                          <a:latin typeface="Calibri"/>
+                        </a:rPr>
+                        <a:t>cleaned dims, placement bridge, sessions, governance</a:t>
+                      </a:r>
+                    </a:p>
+                  </a:txBody>
+                  <a:tcPr marL="73152" marR="73152" marT="27432" marB="27432" anchor="ctr">
+                    <a:solidFill>
+                      <a:srgbClr val="FFFFFF"/>
+                    </a:solidFill>
+                  </a:tcPr>
+                </a:tc>
+              </a:tr>
+              <a:tr h="621792">
+                <a:tc>
+                  <a:txBody>
+                    <a:bodyPr wrap="square"/>
+                    <a:lstStyle/>
+                    <a:p>
+                      <a:r>
+                        <a:rPr sz="1400" b="1">
+                          <a:solidFill>
+                            <a:srgbClr val="222A33"/>
+                          </a:solidFill>
+                          <a:latin typeface="Calibri"/>
+                        </a:rPr>
+                        <a:t>Buys</a:t>
+                      </a:r>
+                    </a:p>
+                  </a:txBody>
+                  <a:tcPr marL="73152" marR="73152" marT="27432" marB="27432" anchor="ctr">
+                    <a:solidFill>
+                      <a:srgbClr val="EDF1F5"/>
+                    </a:solidFill>
+                  </a:tcPr>
+                </a:tc>
+                <a:tc>
+                  <a:txBody>
+                    <a:bodyPr wrap="square"/>
+                    <a:lstStyle/>
+                    <a:p>
+                      <a:r>
+                        <a:rPr sz="1400">
+                          <a:solidFill>
+                            <a:srgbClr val="222A33"/>
+                          </a:solidFill>
+                          <a:latin typeface="Calibri"/>
+                        </a:rPr>
+                        <a:t>stable schema, generic SQL, labels, v1/v2 pool</a:t>
+                      </a:r>
+                    </a:p>
+                  </a:txBody>
+                  <a:tcPr marL="73152" marR="73152" marT="27432" marB="27432" anchor="ctr">
+                    <a:solidFill>
+                      <a:srgbClr val="EDF1F5"/>
+                    </a:solidFill>
+                  </a:tcPr>
+                </a:tc>
+                <a:tc>
+                  <a:txBody>
+                    <a:bodyPr wrap="square"/>
+                    <a:lstStyle/>
+                    <a:p>
+                      <a:r>
+                        <a:rPr sz="1400">
+                          <a:solidFill>
+                            <a:srgbClr val="222A33"/>
+                          </a:solidFill>
+                          <a:latin typeface="Calibri"/>
+                        </a:rPr>
+                        <a:t>true missingness, governed access, marts, view library</a:t>
+                      </a:r>
+                    </a:p>
+                  </a:txBody>
+                  <a:tcPr marL="73152" marR="73152" marT="27432" marB="27432" anchor="ctr">
+                    <a:solidFill>
+                      <a:srgbClr val="EDF1F5"/>
+                    </a:solidFill>
+                  </a:tcPr>
+                </a:tc>
+              </a:tr>
+              <a:tr h="621792">
+                <a:tc>
+                  <a:txBody>
+                    <a:bodyPr wrap="square"/>
+                    <a:lstStyle/>
+                    <a:p>
+                      <a:r>
+                        <a:rPr sz="1400" b="1">
+                          <a:solidFill>
+                            <a:srgbClr val="222A33"/>
+                          </a:solidFill>
+                          <a:latin typeface="Calibri"/>
+                        </a:rPr>
+                        <a:t>Lift</a:t>
+                      </a:r>
+                    </a:p>
+                  </a:txBody>
+                  <a:tcPr marL="73152" marR="73152" marT="27432" marB="27432" anchor="ctr">
+                    <a:solidFill>
+                      <a:srgbClr val="FFFFFF"/>
+                    </a:solidFill>
+                  </a:tcPr>
+                </a:tc>
+                <a:tc>
+                  <a:txBody>
+                    <a:bodyPr wrap="square"/>
+                    <a:lstStyle/>
+                    <a:p>
+                      <a:r>
+                        <a:rPr sz="1400">
+                          <a:solidFill>
+                            <a:srgbClr val="222A33"/>
+                          </a:solidFill>
+                          <a:latin typeface="Calibri"/>
+                        </a:rPr>
+                        <a:t>low — reuses CleanConnect + dictionary</a:t>
+                      </a:r>
+                    </a:p>
+                  </a:txBody>
+                  <a:tcPr marL="73152" marR="73152" marT="27432" marB="27432" anchor="ctr">
+                    <a:solidFill>
+                      <a:srgbClr val="FFFFFF"/>
+                    </a:solidFill>
+                  </a:tcPr>
+                </a:tc>
+                <a:tc>
+                  <a:txBody>
+                    <a:bodyPr wrap="square"/>
+                    <a:lstStyle/>
+                    <a:p>
+                      <a:r>
+                        <a:rPr sz="1400">
+                          <a:solidFill>
+                            <a:srgbClr val="222A33"/>
+                          </a:solidFill>
+                          <a:latin typeface="Calibri"/>
+                        </a:rPr>
+                        <a:t>larger, phased — builds on Phase 1's fact</a:t>
+                      </a:r>
+                    </a:p>
+                  </a:txBody>
+                  <a:tcPr marL="73152" marR="73152" marT="27432" marB="27432" anchor="ctr">
+                    <a:solidFill>
+                      <a:srgbClr val="FFFFFF"/>
+                    </a:solidFill>
+                  </a:tcPr>
+                </a:tc>
+              </a:tr>
+              <a:tr h="621792">
+                <a:tc>
+                  <a:txBody>
+                    <a:bodyPr wrap="square"/>
+                    <a:lstStyle/>
+                    <a:p>
+                      <a:r>
+                        <a:rPr sz="1400" b="1">
+                          <a:solidFill>
+                            <a:srgbClr val="222A33"/>
+                          </a:solidFill>
+                          <a:latin typeface="Calibri"/>
+                        </a:rPr>
+                        <a:t>Release-ready</a:t>
+                      </a:r>
+                    </a:p>
+                  </a:txBody>
+                  <a:tcPr marL="73152" marR="73152" marT="27432" marB="27432" anchor="ctr">
+                    <a:solidFill>
+                      <a:srgbClr val="EDF1F5"/>
+                    </a:solidFill>
+                  </a:tcPr>
+                </a:tc>
+                <a:tc>
+                  <a:txBody>
+                    <a:bodyPr wrap="square"/>
+                    <a:lstStyle/>
+                    <a:p>
+                      <a:r>
+                        <a:rPr sz="1400">
+                          <a:solidFill>
+                            <a:srgbClr val="222A33"/>
+                          </a:solidFill>
+                          <a:latin typeface="Calibri"/>
+                        </a:rPr>
+                        <a:t>internal / analyst only</a:t>
+                      </a:r>
+                    </a:p>
+                  </a:txBody>
+                  <a:tcPr marL="73152" marR="73152" marT="27432" marB="27432" anchor="ctr">
+                    <a:solidFill>
+                      <a:srgbClr val="EDF1F5"/>
+                    </a:solidFill>
+                  </a:tcPr>
+                </a:tc>
+                <a:tc>
+                  <a:txBody>
+                    <a:bodyPr wrap="square"/>
+                    <a:lstStyle/>
+                    <a:p>
+                      <a:r>
+                        <a:rPr sz="1400">
+                          <a:solidFill>
+                            <a:srgbClr val="222A33"/>
+                          </a:solidFill>
+                          <a:latin typeface="Calibri"/>
+                        </a:rPr>
+                        <a:t>yes — external PR2 sharing</a:t>
+                      </a:r>
+                    </a:p>
+                  </a:txBody>
+                  <a:tcPr marL="73152" marR="73152" marT="27432" marB="27432" anchor="ctr">
+                    <a:solidFill>
+                      <a:srgbClr val="EDF1F5"/>
+                    </a:solidFill>
+                  </a:tcPr>
+                </a:tc>
+              </a:tr>
+            </a:tbl>
+          </a:graphicData>
+        </a:graphic>
+      </p:graphicFrame>
+      <p:sp>
+        <p:nvSpPr>
+          <p:cNvPr id="5" name="TextBox 4"/>
+          <p:cNvSpPr txBox="1"/>
+          <p:nvPr/>
+        </p:nvSpPr>
+        <p:spPr>
+          <a:xfrm>
+            <a:off x="548640" y="5120640"/>
+            <a:ext cx="11064240" cy="548640"/>
+          </a:xfrm>
+          <a:prstGeom prst="rect">
+            <a:avLst/>
+          </a:prstGeom>
+          <a:noFill/>
+        </p:spPr>
+        <p:txBody>
+          <a:bodyPr wrap="square">
+            <a:spAutoFit/>
+          </a:bodyPr>
+          <a:lstStyle/>
+          <a:p>
+            <a:pPr algn="l"/>
+            <a:r>
+              <a:rPr sz="1500" b="0" i="1">
+                <a:solidFill>
+                  <a:srgbClr val="5A636E"/>
+                </a:solidFill>
+                <a:latin typeface="Calibri"/>
+              </a:rPr>
+              <a:t>Same responses fact both phases — Phase 1 is a down payment, not throwaway work.</a:t>
+            </a:r>
+          </a:p>
+        </p:txBody>
+      </p:sp>
+    </p:spTree>
+  </p:cSld>
+  <p:clrMapOvr>
+    <a:masterClrMapping/>
+  </p:clrMapOvr>
+</p:sld>
+</file>
+
+<file path=ppt/slides/slide11.xml><?xml version="1.0" encoding="utf-8"?>
+<p:sld xmlns:a="http://schemas.openxmlformats.org/drawingml/2006/main" xmlns:p="http://schemas.openxmlformats.org/presentationml/2006/main" xmlns:r="http://schemas.openxmlformats.org/officeDocument/2006/relationships">
+  <p:cSld>
+    <p:spTree>
+      <p:nvGrpSpPr>
+        <p:cNvPr id="1" name=""/>
+        <p:cNvGrpSpPr/>
+        <p:nvPr/>
+      </p:nvGrpSpPr>
+      <p:grpSpPr/>
+      <p:sp>
+        <p:nvSpPr>
+          <p:cNvPr id="2" name="Rectangle 1"/>
+          <p:cNvSpPr/>
+          <p:nvPr/>
+        </p:nvSpPr>
+        <p:spPr>
+          <a:xfrm>
+            <a:off x="0" y="0"/>
+            <a:ext cx="12191695" cy="1051560"/>
+          </a:xfrm>
+          <a:prstGeom prst="rect">
+            <a:avLst/>
+          </a:prstGeom>
+          <a:solidFill>
+            <a:srgbClr val="16324F"/>
+          </a:solidFill>
+          <a:ln>
+            <a:noFill/>
+          </a:ln>
+          <a:effectLst/>
+        </p:spPr>
+        <p:style>
+          <a:lnRef idx="1">
+            <a:schemeClr val="accent1"/>
+          </a:lnRef>
+          <a:fillRef idx="3">
+            <a:schemeClr val="accent1"/>
+          </a:fillRef>
+          <a:effectRef idx="2">
+            <a:schemeClr val="accent1"/>
+          </a:effectRef>
+          <a:fontRef idx="minor">
+            <a:schemeClr val="lt1"/>
+          </a:fontRef>
+        </p:style>
+        <p:txBody>
+          <a:bodyPr rtlCol="0" anchor="ctr" lIns="457200" tIns="109728"/>
+          <a:lstStyle/>
+          <a:p>
+            <a:pPr algn="ctr"/>
+            <a:r>
+              <a:rPr sz="2800" b="1">
+                <a:solidFill>
+                  <a:srgbClr val="FFFFFF"/>
+                </a:solidFill>
+                <a:latin typeface="Calibri"/>
+              </a:rPr>
               <a:t>Phase 2 — the full model</a:t>
             </a:r>
           </a:p>
@@ -4958,7 +5769,7 @@
 </p:sld>
 </file>
 
-<file path=ppt/slides/slide11.xml><?xml version="1.0" encoding="utf-8"?>
+<file path=ppt/slides/slide12.xml><?xml version="1.0" encoding="utf-8"?>
 <p:sld xmlns:a="http://schemas.openxmlformats.org/drawingml/2006/main" xmlns:p="http://schemas.openxmlformats.org/presentationml/2006/main" xmlns:r="http://schemas.openxmlformats.org/officeDocument/2006/relationships">
   <p:cSld>
     <p:spTree>
@@ -5520,7 +6331,7 @@
 </p:sld>
 </file>
 
-<file path=ppt/slides/slide12.xml><?xml version="1.0" encoding="utf-8"?>
+<file path=ppt/slides/slide13.xml><?xml version="1.0" encoding="utf-8"?>
 <p:sld xmlns:a="http://schemas.openxmlformats.org/drawingml/2006/main" xmlns:p="http://schemas.openxmlformats.org/presentationml/2006/main" xmlns:r="http://schemas.openxmlformats.org/officeDocument/2006/relationships">
   <p:cSld>
     <p:spTree>
@@ -5767,7 +6578,7 @@
 </p:sld>
 </file>
 
-<file path=ppt/slides/slide13.xml><?xml version="1.0" encoding="utf-8"?>
+<file path=ppt/slides/slide14.xml><?xml version="1.0" encoding="utf-8"?>
 <p:sld xmlns:a="http://schemas.openxmlformats.org/drawingml/2006/main" xmlns:p="http://schemas.openxmlformats.org/presentationml/2006/main" xmlns:r="http://schemas.openxmlformats.org/officeDocument/2006/relationships">
   <p:cSld>
     <p:spTree>
@@ -5951,7 +6762,7 @@
 </p:sld>
 </file>
 
-<file path=ppt/slides/slide14.xml><?xml version="1.0" encoding="utf-8"?>
+<file path=ppt/slides/slide15.xml><?xml version="1.0" encoding="utf-8"?>
 <p:sld xmlns:a="http://schemas.openxmlformats.org/drawingml/2006/main" xmlns:p="http://schemas.openxmlformats.org/presentationml/2006/main" xmlns:r="http://schemas.openxmlformats.org/officeDocument/2006/relationships">
   <p:cSld>
     <p:spTree>
@@ -6616,7 +7427,7 @@
 </p:sld>
 </file>
 
-<file path=ppt/slides/slide15.xml><?xml version="1.0" encoding="utf-8"?>
+<file path=ppt/slides/slide16.xml><?xml version="1.0" encoding="utf-8"?>
 <p:sld xmlns:a="http://schemas.openxmlformats.org/drawingml/2006/main" xmlns:p="http://schemas.openxmlformats.org/presentationml/2006/main" xmlns:r="http://schemas.openxmlformats.org/officeDocument/2006/relationships">
   <p:cSld>
     <p:spTree>
@@ -7344,7 +8155,3273 @@
 </p:sld>
 </file>
 
-<file path=ppt/slides/slide16.xml><?xml version="1.0" encoding="utf-8"?>
+<file path=ppt/slides/slide17.xml><?xml version="1.0" encoding="utf-8"?>
+<p:sld xmlns:a="http://schemas.openxmlformats.org/drawingml/2006/main" xmlns:p="http://schemas.openxmlformats.org/presentationml/2006/main" xmlns:r="http://schemas.openxmlformats.org/officeDocument/2006/relationships">
+  <p:cSld>
+    <p:spTree>
+      <p:nvGrpSpPr>
+        <p:cNvPr id="1" name=""/>
+        <p:cNvGrpSpPr/>
+        <p:nvPr/>
+      </p:nvGrpSpPr>
+      <p:grpSpPr/>
+      <p:sp>
+        <p:nvSpPr>
+          <p:cNvPr id="2" name="Rectangle 1"/>
+          <p:cNvSpPr/>
+          <p:nvPr/>
+        </p:nvSpPr>
+        <p:spPr>
+          <a:xfrm>
+            <a:off x="0" y="0"/>
+            <a:ext cx="12191695" cy="1051560"/>
+          </a:xfrm>
+          <a:prstGeom prst="rect">
+            <a:avLst/>
+          </a:prstGeom>
+          <a:solidFill>
+            <a:srgbClr val="16324F"/>
+          </a:solidFill>
+          <a:ln>
+            <a:noFill/>
+          </a:ln>
+          <a:effectLst/>
+        </p:spPr>
+        <p:style>
+          <a:lnRef idx="1">
+            <a:schemeClr val="accent1"/>
+          </a:lnRef>
+          <a:fillRef idx="3">
+            <a:schemeClr val="accent1"/>
+          </a:fillRef>
+          <a:effectRef idx="2">
+            <a:schemeClr val="accent1"/>
+          </a:effectRef>
+          <a:fontRef idx="minor">
+            <a:schemeClr val="lt1"/>
+          </a:fontRef>
+        </p:style>
+        <p:txBody>
+          <a:bodyPr rtlCol="0" anchor="ctr" lIns="457200" tIns="109728"/>
+          <a:lstStyle/>
+          <a:p>
+            <a:pPr algn="ctr"/>
+            <a:r>
+              <a:rPr sz="2800" b="1">
+                <a:solidFill>
+                  <a:srgbClr val="FFFFFF"/>
+                </a:solidFill>
+                <a:latin typeface="Calibri"/>
+              </a:rPr>
+              <a:t>Analyzing long format (1/3) — labels are one join away</a:t>
+            </a:r>
+          </a:p>
+          <a:p>
+            <a:r>
+              <a:rPr sz="1300" i="1">
+                <a:solidFill>
+                  <a:srgbClr val="BBD5D7"/>
+                </a:solidFill>
+              </a:rPr>
+              <a:t>Every row says what it means: concept id + human label, side by side</a:t>
+            </a:r>
+          </a:p>
+        </p:txBody>
+      </p:sp>
+      <p:sp>
+        <p:nvSpPr>
+          <p:cNvPr id="3" name="Rectangle 2"/>
+          <p:cNvSpPr/>
+          <p:nvPr/>
+        </p:nvSpPr>
+        <p:spPr>
+          <a:xfrm>
+            <a:off x="0" y="1051560"/>
+            <a:ext cx="12191695" cy="54864"/>
+          </a:xfrm>
+          <a:prstGeom prst="rect">
+            <a:avLst/>
+          </a:prstGeom>
+          <a:solidFill>
+            <a:srgbClr val="2E8B8B"/>
+          </a:solidFill>
+          <a:ln>
+            <a:noFill/>
+          </a:ln>
+          <a:effectLst/>
+        </p:spPr>
+        <p:style>
+          <a:lnRef idx="1">
+            <a:schemeClr val="accent1"/>
+          </a:lnRef>
+          <a:fillRef idx="3">
+            <a:schemeClr val="accent1"/>
+          </a:fillRef>
+          <a:effectRef idx="2">
+            <a:schemeClr val="accent1"/>
+          </a:effectRef>
+          <a:fontRef idx="minor">
+            <a:schemeClr val="lt1"/>
+          </a:fontRef>
+        </p:style>
+        <p:txBody>
+          <a:bodyPr rtlCol="0" anchor="ctr"/>
+          <a:lstStyle/>
+          <a:p>
+            <a:pPr algn="ctr"/>
+          </a:p>
+        </p:txBody>
+      </p:sp>
+      <p:sp>
+        <p:nvSpPr>
+          <p:cNvPr id="4" name="Rectangle 3"/>
+          <p:cNvSpPr/>
+          <p:nvPr/>
+        </p:nvSpPr>
+        <p:spPr>
+          <a:xfrm>
+            <a:off x="457200" y="1325880"/>
+            <a:ext cx="5577840" cy="2468880"/>
+          </a:xfrm>
+          <a:prstGeom prst="rect">
+            <a:avLst/>
+          </a:prstGeom>
+          <a:solidFill>
+            <a:srgbClr val="1E2935"/>
+          </a:solidFill>
+          <a:ln>
+            <a:solidFill>
+              <a:srgbClr val="2E8B8B"/>
+            </a:solidFill>
+          </a:ln>
+          <a:effectLst/>
+        </p:spPr>
+        <p:style>
+          <a:lnRef idx="1">
+            <a:schemeClr val="accent1"/>
+          </a:lnRef>
+          <a:fillRef idx="3">
+            <a:schemeClr val="accent1"/>
+          </a:fillRef>
+          <a:effectRef idx="2">
+            <a:schemeClr val="accent1"/>
+          </a:effectRef>
+          <a:fontRef idx="minor">
+            <a:schemeClr val="lt1"/>
+          </a:fontRef>
+        </p:style>
+        <p:txBody>
+          <a:bodyPr rtlCol="0" anchor="t" wrap="square" lIns="182880" rIns="137160" tIns="109728"/>
+          <a:lstStyle/>
+          <a:p>
+            <a:pPr algn="ctr">
+              <a:lnSpc>
+                <a:spcPct val="100000"/>
+              </a:lnSpc>
+            </a:pPr>
+            <a:r>
+              <a:rPr sz="1250">
+                <a:solidFill>
+                  <a:srgbClr val="8BA6C0"/>
+                </a:solidFill>
+                <a:latin typeface="Courier New"/>
+              </a:rPr>
+              <a:t>-- one join attaches a label to every answer</a:t>
+            </a:r>
+          </a:p>
+          <a:p>
+            <a:pPr>
+              <a:lnSpc>
+                <a:spcPct val="100000"/>
+              </a:lnSpc>
+            </a:pPr>
+            <a:r>
+              <a:rPr sz="1250">
+                <a:solidFill>
+                  <a:srgbClr val="E6EDF3"/>
+                </a:solidFill>
+                <a:latin typeface="Courier New"/>
+              </a:rPr>
+              <a:t>SELECT connect_id, question_text,</a:t>
+            </a:r>
+          </a:p>
+          <a:p>
+            <a:pPr>
+              <a:lnSpc>
+                <a:spcPct val="100000"/>
+              </a:lnSpc>
+            </a:pPr>
+            <a:r>
+              <a:rPr sz="1250">
+                <a:solidFill>
+                  <a:srgbClr val="E6EDF3"/>
+                </a:solidFill>
+                <a:latin typeface="Courier New"/>
+              </a:rPr>
+              <a:t>       response_concept_id, response_label, value</a:t>
+            </a:r>
+          </a:p>
+          <a:p>
+            <a:pPr>
+              <a:lnSpc>
+                <a:spcPct val="100000"/>
+              </a:lnSpc>
+            </a:pPr>
+            <a:r>
+              <a:rPr sz="1250">
+                <a:solidFill>
+                  <a:srgbClr val="E6EDF3"/>
+                </a:solidFill>
+                <a:latin typeface="Courier New"/>
+              </a:rPr>
+              <a:t>FROM responses</a:t>
+            </a:r>
+          </a:p>
+          <a:p>
+            <a:pPr>
+              <a:lnSpc>
+                <a:spcPct val="100000"/>
+              </a:lnSpc>
+            </a:pPr>
+            <a:r>
+              <a:rPr sz="1250">
+                <a:solidFill>
+                  <a:srgbClr val="E6EDF3"/>
+                </a:solidFill>
+                <a:latin typeface="Courier New"/>
+              </a:rPr>
+              <a:t>JOIN question USING (question_concept_id)</a:t>
+            </a:r>
+          </a:p>
+          <a:p>
+            <a:pPr>
+              <a:lnSpc>
+                <a:spcPct val="100000"/>
+              </a:lnSpc>
+            </a:pPr>
+            <a:r>
+              <a:rPr sz="1250">
+                <a:solidFill>
+                  <a:srgbClr val="E6EDF3"/>
+                </a:solidFill>
+                <a:latin typeface="Courier New"/>
+              </a:rPr>
+              <a:t>LEFT JOIN response USING (response_concept_id)</a:t>
+            </a:r>
+          </a:p>
+          <a:p>
+            <a:pPr>
+              <a:lnSpc>
+                <a:spcPct val="100000"/>
+              </a:lnSpc>
+            </a:pPr>
+            <a:r>
+              <a:rPr sz="1250">
+                <a:solidFill>
+                  <a:srgbClr val="E6EDF3"/>
+                </a:solidFill>
+                <a:latin typeface="Courier New"/>
+              </a:rPr>
+              <a:t>WHERE connect_id = 1001;</a:t>
+            </a:r>
+          </a:p>
+        </p:txBody>
+      </p:sp>
+      <p:graphicFrame>
+        <p:nvGraphicFramePr>
+          <p:cNvPr id="5" name="Table 4"/>
+          <p:cNvGraphicFramePr>
+            <a:graphicFrameLocks noGrp="1"/>
+          </p:cNvGraphicFramePr>
+          <p:nvPr/>
+        </p:nvGraphicFramePr>
+        <p:xfrm>
+          <a:off x="6217920" y="1325880"/>
+          <a:ext cx="5486400" cy="2468880"/>
+        </p:xfrm>
+        <a:graphic>
+          <a:graphicData uri="http://schemas.openxmlformats.org/drawingml/2006/table">
+            <a:tbl>
+              <a:tblPr firstRow="1" bandRow="1">
+                <a:tableStyleId>{5C22544A-7EE6-4342-B048-85BDC9FD1C3A}</a:tableStyleId>
+              </a:tblPr>
+              <a:tblGrid>
+                <a:gridCol w="1554480"/>
+                <a:gridCol w="1005840"/>
+                <a:gridCol w="2377440"/>
+                <a:gridCol w="548640"/>
+              </a:tblGrid>
+              <a:tr h="352697">
+                <a:tc>
+                  <a:txBody>
+                    <a:bodyPr wrap="square"/>
+                    <a:lstStyle/>
+                    <a:p>
+                      <a:r>
+                        <a:rPr b="1" sz="1050">
+                          <a:solidFill>
+                            <a:srgbClr val="FFFFFF"/>
+                          </a:solidFill>
+                          <a:latin typeface="Calibri"/>
+                        </a:rPr>
+                        <a:t>question_text</a:t>
+                      </a:r>
+                    </a:p>
+                  </a:txBody>
+                  <a:tcPr marL="73152" marR="73152" marT="27432" marB="27432" anchor="ctr">
+                    <a:solidFill>
+                      <a:srgbClr val="16324F"/>
+                    </a:solidFill>
+                  </a:tcPr>
+                </a:tc>
+                <a:tc>
+                  <a:txBody>
+                    <a:bodyPr wrap="square"/>
+                    <a:lstStyle/>
+                    <a:p>
+                      <a:r>
+                        <a:rPr b="1" sz="1050">
+                          <a:solidFill>
+                            <a:srgbClr val="FFFFFF"/>
+                          </a:solidFill>
+                          <a:latin typeface="Calibri"/>
+                        </a:rPr>
+                        <a:t>resp. id</a:t>
+                      </a:r>
+                    </a:p>
+                  </a:txBody>
+                  <a:tcPr marL="73152" marR="73152" marT="27432" marB="27432" anchor="ctr">
+                    <a:solidFill>
+                      <a:srgbClr val="16324F"/>
+                    </a:solidFill>
+                  </a:tcPr>
+                </a:tc>
+                <a:tc>
+                  <a:txBody>
+                    <a:bodyPr wrap="square"/>
+                    <a:lstStyle/>
+                    <a:p>
+                      <a:r>
+                        <a:rPr b="1" sz="1050">
+                          <a:solidFill>
+                            <a:srgbClr val="FFFFFF"/>
+                          </a:solidFill>
+                          <a:latin typeface="Calibri"/>
+                        </a:rPr>
+                        <a:t>response_label</a:t>
+                      </a:r>
+                    </a:p>
+                  </a:txBody>
+                  <a:tcPr marL="73152" marR="73152" marT="27432" marB="27432" anchor="ctr">
+                    <a:solidFill>
+                      <a:srgbClr val="16324F"/>
+                    </a:solidFill>
+                  </a:tcPr>
+                </a:tc>
+                <a:tc>
+                  <a:txBody>
+                    <a:bodyPr wrap="square"/>
+                    <a:lstStyle/>
+                    <a:p>
+                      <a:r>
+                        <a:rPr b="1" sz="1050">
+                          <a:solidFill>
+                            <a:srgbClr val="FFFFFF"/>
+                          </a:solidFill>
+                          <a:latin typeface="Calibri"/>
+                        </a:rPr>
+                        <a:t>value</a:t>
+                      </a:r>
+                    </a:p>
+                  </a:txBody>
+                  <a:tcPr marL="73152" marR="73152" marT="27432" marB="27432" anchor="ctr">
+                    <a:solidFill>
+                      <a:srgbClr val="16324F"/>
+                    </a:solidFill>
+                  </a:tcPr>
+                </a:tc>
+              </a:tr>
+              <a:tr h="352697">
+                <a:tc>
+                  <a:txBody>
+                    <a:bodyPr wrap="square"/>
+                    <a:lstStyle/>
+                    <a:p>
+                      <a:r>
+                        <a:rPr sz="1050" b="1">
+                          <a:solidFill>
+                            <a:srgbClr val="222A33"/>
+                          </a:solidFill>
+                          <a:latin typeface="Calibri"/>
+                        </a:rPr>
+                        <a:t>Sex</a:t>
+                      </a:r>
+                    </a:p>
+                  </a:txBody>
+                  <a:tcPr marL="73152" marR="73152" marT="27432" marB="27432" anchor="ctr">
+                    <a:solidFill>
+                      <a:srgbClr val="FFFFFF"/>
+                    </a:solidFill>
+                  </a:tcPr>
+                </a:tc>
+                <a:tc>
+                  <a:txBody>
+                    <a:bodyPr wrap="square"/>
+                    <a:lstStyle/>
+                    <a:p>
+                      <a:r>
+                        <a:rPr sz="1050">
+                          <a:solidFill>
+                            <a:srgbClr val="222A33"/>
+                          </a:solidFill>
+                          <a:latin typeface="Calibri"/>
+                        </a:rPr>
+                        <a:t>536341288</a:t>
+                      </a:r>
+                    </a:p>
+                  </a:txBody>
+                  <a:tcPr marL="73152" marR="73152" marT="27432" marB="27432" anchor="ctr">
+                    <a:solidFill>
+                      <a:srgbClr val="FFFFFF"/>
+                    </a:solidFill>
+                  </a:tcPr>
+                </a:tc>
+                <a:tc>
+                  <a:txBody>
+                    <a:bodyPr wrap="square"/>
+                    <a:lstStyle/>
+                    <a:p>
+                      <a:r>
+                        <a:rPr sz="1050">
+                          <a:solidFill>
+                            <a:srgbClr val="222A33"/>
+                          </a:solidFill>
+                          <a:latin typeface="Calibri"/>
+                        </a:rPr>
+                        <a:t>Female</a:t>
+                      </a:r>
+                    </a:p>
+                  </a:txBody>
+                  <a:tcPr marL="73152" marR="73152" marT="27432" marB="27432" anchor="ctr">
+                    <a:solidFill>
+                      <a:srgbClr val="FFFFFF"/>
+                    </a:solidFill>
+                  </a:tcPr>
+                </a:tc>
+                <a:tc>
+                  <a:txBody>
+                    <a:bodyPr wrap="square"/>
+                    <a:lstStyle/>
+                    <a:p>
+                      <a:r>
+                        <a:rPr sz="1050">
+                          <a:solidFill>
+                            <a:srgbClr val="222A33"/>
+                          </a:solidFill>
+                          <a:latin typeface="Calibri"/>
+                        </a:rPr>
+                        <a:t/>
+                      </a:r>
+                    </a:p>
+                  </a:txBody>
+                  <a:tcPr marL="73152" marR="73152" marT="27432" marB="27432" anchor="ctr">
+                    <a:solidFill>
+                      <a:srgbClr val="FFFFFF"/>
+                    </a:solidFill>
+                  </a:tcPr>
+                </a:tc>
+              </a:tr>
+              <a:tr h="352697">
+                <a:tc>
+                  <a:txBody>
+                    <a:bodyPr wrap="square"/>
+                    <a:lstStyle/>
+                    <a:p>
+                      <a:r>
+                        <a:rPr sz="1050" b="1">
+                          <a:solidFill>
+                            <a:srgbClr val="222A33"/>
+                          </a:solidFill>
+                          <a:latin typeface="Calibri"/>
+                        </a:rPr>
+                        <a:t>Age</a:t>
+                      </a:r>
+                    </a:p>
+                  </a:txBody>
+                  <a:tcPr marL="73152" marR="73152" marT="27432" marB="27432" anchor="ctr">
+                    <a:solidFill>
+                      <a:srgbClr val="EDF1F5"/>
+                    </a:solidFill>
+                  </a:tcPr>
+                </a:tc>
+                <a:tc>
+                  <a:txBody>
+                    <a:bodyPr wrap="square"/>
+                    <a:lstStyle/>
+                    <a:p>
+                      <a:r>
+                        <a:rPr sz="1050">
+                          <a:solidFill>
+                            <a:srgbClr val="222A33"/>
+                          </a:solidFill>
+                          <a:latin typeface="Calibri"/>
+                        </a:rPr>
+                        <a:t/>
+                      </a:r>
+                    </a:p>
+                  </a:txBody>
+                  <a:tcPr marL="73152" marR="73152" marT="27432" marB="27432" anchor="ctr">
+                    <a:solidFill>
+                      <a:srgbClr val="EDF1F5"/>
+                    </a:solidFill>
+                  </a:tcPr>
+                </a:tc>
+                <a:tc>
+                  <a:txBody>
+                    <a:bodyPr wrap="square"/>
+                    <a:lstStyle/>
+                    <a:p>
+                      <a:r>
+                        <a:rPr sz="1050">
+                          <a:solidFill>
+                            <a:srgbClr val="222A33"/>
+                          </a:solidFill>
+                          <a:latin typeface="Calibri"/>
+                        </a:rPr>
+                        <a:t/>
+                      </a:r>
+                    </a:p>
+                  </a:txBody>
+                  <a:tcPr marL="73152" marR="73152" marT="27432" marB="27432" anchor="ctr">
+                    <a:solidFill>
+                      <a:srgbClr val="EDF1F5"/>
+                    </a:solidFill>
+                  </a:tcPr>
+                </a:tc>
+                <a:tc>
+                  <a:txBody>
+                    <a:bodyPr wrap="square"/>
+                    <a:lstStyle/>
+                    <a:p>
+                      <a:r>
+                        <a:rPr sz="1050">
+                          <a:solidFill>
+                            <a:srgbClr val="222A33"/>
+                          </a:solidFill>
+                          <a:latin typeface="Calibri"/>
+                        </a:rPr>
+                        <a:t>47</a:t>
+                      </a:r>
+                    </a:p>
+                  </a:txBody>
+                  <a:tcPr marL="73152" marR="73152" marT="27432" marB="27432" anchor="ctr">
+                    <a:solidFill>
+                      <a:srgbClr val="EDF1F5"/>
+                    </a:solidFill>
+                  </a:tcPr>
+                </a:tc>
+              </a:tr>
+              <a:tr h="352697">
+                <a:tc>
+                  <a:txBody>
+                    <a:bodyPr wrap="square"/>
+                    <a:lstStyle/>
+                    <a:p>
+                      <a:r>
+                        <a:rPr sz="1050" b="1">
+                          <a:solidFill>
+                            <a:srgbClr val="222A33"/>
+                          </a:solidFill>
+                          <a:latin typeface="Calibri"/>
+                        </a:rPr>
+                        <a:t>Smoking Status</a:t>
+                      </a:r>
+                    </a:p>
+                  </a:txBody>
+                  <a:tcPr marL="73152" marR="73152" marT="27432" marB="27432" anchor="ctr">
+                    <a:solidFill>
+                      <a:srgbClr val="FFFFFF"/>
+                    </a:solidFill>
+                  </a:tcPr>
+                </a:tc>
+                <a:tc>
+                  <a:txBody>
+                    <a:bodyPr wrap="square"/>
+                    <a:lstStyle/>
+                    <a:p>
+                      <a:r>
+                        <a:rPr sz="1050">
+                          <a:solidFill>
+                            <a:srgbClr val="222A33"/>
+                          </a:solidFill>
+                          <a:latin typeface="Calibri"/>
+                        </a:rPr>
+                        <a:t>700000002</a:t>
+                      </a:r>
+                    </a:p>
+                  </a:txBody>
+                  <a:tcPr marL="73152" marR="73152" marT="27432" marB="27432" anchor="ctr">
+                    <a:solidFill>
+                      <a:srgbClr val="FFFFFF"/>
+                    </a:solidFill>
+                  </a:tcPr>
+                </a:tc>
+                <a:tc>
+                  <a:txBody>
+                    <a:bodyPr wrap="square"/>
+                    <a:lstStyle/>
+                    <a:p>
+                      <a:r>
+                        <a:rPr sz="1050">
+                          <a:solidFill>
+                            <a:srgbClr val="222A33"/>
+                          </a:solidFill>
+                          <a:latin typeface="Calibri"/>
+                        </a:rPr>
+                        <a:t>Former</a:t>
+                      </a:r>
+                    </a:p>
+                  </a:txBody>
+                  <a:tcPr marL="73152" marR="73152" marT="27432" marB="27432" anchor="ctr">
+                    <a:solidFill>
+                      <a:srgbClr val="FFFFFF"/>
+                    </a:solidFill>
+                  </a:tcPr>
+                </a:tc>
+                <a:tc>
+                  <a:txBody>
+                    <a:bodyPr wrap="square"/>
+                    <a:lstStyle/>
+                    <a:p>
+                      <a:r>
+                        <a:rPr sz="1050">
+                          <a:solidFill>
+                            <a:srgbClr val="222A33"/>
+                          </a:solidFill>
+                          <a:latin typeface="Calibri"/>
+                        </a:rPr>
+                        <a:t/>
+                      </a:r>
+                    </a:p>
+                  </a:txBody>
+                  <a:tcPr marL="73152" marR="73152" marT="27432" marB="27432" anchor="ctr">
+                    <a:solidFill>
+                      <a:srgbClr val="FFFFFF"/>
+                    </a:solidFill>
+                  </a:tcPr>
+                </a:tc>
+              </a:tr>
+              <a:tr h="352697">
+                <a:tc>
+                  <a:txBody>
+                    <a:bodyPr wrap="square"/>
+                    <a:lstStyle/>
+                    <a:p>
+                      <a:r>
+                        <a:rPr sz="1050" b="1">
+                          <a:solidFill>
+                            <a:srgbClr val="222A33"/>
+                          </a:solidFill>
+                          <a:latin typeface="Calibri"/>
+                        </a:rPr>
+                        <a:t>Education</a:t>
+                      </a:r>
+                    </a:p>
+                  </a:txBody>
+                  <a:tcPr marL="73152" marR="73152" marT="27432" marB="27432" anchor="ctr">
+                    <a:solidFill>
+                      <a:srgbClr val="EDF1F5"/>
+                    </a:solidFill>
+                  </a:tcPr>
+                </a:tc>
+                <a:tc>
+                  <a:txBody>
+                    <a:bodyPr wrap="square"/>
+                    <a:lstStyle/>
+                    <a:p>
+                      <a:r>
+                        <a:rPr sz="1050">
+                          <a:solidFill>
+                            <a:srgbClr val="222A33"/>
+                          </a:solidFill>
+                          <a:latin typeface="Calibri"/>
+                        </a:rPr>
+                        <a:t>875342283</a:t>
+                      </a:r>
+                    </a:p>
+                  </a:txBody>
+                  <a:tcPr marL="73152" marR="73152" marT="27432" marB="27432" anchor="ctr">
+                    <a:solidFill>
+                      <a:srgbClr val="EDF1F5"/>
+                    </a:solidFill>
+                  </a:tcPr>
+                </a:tc>
+                <a:tc>
+                  <a:txBody>
+                    <a:bodyPr wrap="square"/>
+                    <a:lstStyle/>
+                    <a:p>
+                      <a:r>
+                        <a:rPr sz="1050">
+                          <a:solidFill>
+                            <a:srgbClr val="222A33"/>
+                          </a:solidFill>
+                          <a:latin typeface="Calibri"/>
+                        </a:rPr>
+                        <a:t>Bachelor's Degree</a:t>
+                      </a:r>
+                    </a:p>
+                  </a:txBody>
+                  <a:tcPr marL="73152" marR="73152" marT="27432" marB="27432" anchor="ctr">
+                    <a:solidFill>
+                      <a:srgbClr val="EDF1F5"/>
+                    </a:solidFill>
+                  </a:tcPr>
+                </a:tc>
+                <a:tc>
+                  <a:txBody>
+                    <a:bodyPr wrap="square"/>
+                    <a:lstStyle/>
+                    <a:p>
+                      <a:r>
+                        <a:rPr sz="1050">
+                          <a:solidFill>
+                            <a:srgbClr val="222A33"/>
+                          </a:solidFill>
+                          <a:latin typeface="Calibri"/>
+                        </a:rPr>
+                        <a:t/>
+                      </a:r>
+                    </a:p>
+                  </a:txBody>
+                  <a:tcPr marL="73152" marR="73152" marT="27432" marB="27432" anchor="ctr">
+                    <a:solidFill>
+                      <a:srgbClr val="EDF1F5"/>
+                    </a:solidFill>
+                  </a:tcPr>
+                </a:tc>
+              </a:tr>
+              <a:tr h="352697">
+                <a:tc>
+                  <a:txBody>
+                    <a:bodyPr wrap="square"/>
+                    <a:lstStyle/>
+                    <a:p>
+                      <a:r>
+                        <a:rPr sz="1050" b="1">
+                          <a:solidFill>
+                            <a:srgbClr val="222A33"/>
+                          </a:solidFill>
+                          <a:latin typeface="Calibri"/>
+                        </a:rPr>
+                        <a:t>Have you lost…teeth?</a:t>
+                      </a:r>
+                    </a:p>
+                  </a:txBody>
+                  <a:tcPr marL="73152" marR="73152" marT="27432" marB="27432" anchor="ctr">
+                    <a:solidFill>
+                      <a:srgbClr val="FFFFFF"/>
+                    </a:solidFill>
+                  </a:tcPr>
+                </a:tc>
+                <a:tc>
+                  <a:txBody>
+                    <a:bodyPr wrap="square"/>
+                    <a:lstStyle/>
+                    <a:p>
+                      <a:r>
+                        <a:rPr sz="1050">
+                          <a:solidFill>
+                            <a:srgbClr val="222A33"/>
+                          </a:solidFill>
+                          <a:latin typeface="Calibri"/>
+                        </a:rPr>
+                        <a:t>812107266</a:t>
+                      </a:r>
+                    </a:p>
+                  </a:txBody>
+                  <a:tcPr marL="73152" marR="73152" marT="27432" marB="27432" anchor="ctr">
+                    <a:solidFill>
+                      <a:srgbClr val="FFFFFF"/>
+                    </a:solidFill>
+                  </a:tcPr>
+                </a:tc>
+                <a:tc>
+                  <a:txBody>
+                    <a:bodyPr wrap="square"/>
+                    <a:lstStyle/>
+                    <a:p>
+                      <a:r>
+                        <a:rPr sz="1050">
+                          <a:solidFill>
+                            <a:srgbClr val="222A33"/>
+                          </a:solidFill>
+                          <a:latin typeface="Calibri"/>
+                        </a:rPr>
+                        <a:t>Yes, from accident or injury</a:t>
+                      </a:r>
+                    </a:p>
+                  </a:txBody>
+                  <a:tcPr marL="73152" marR="73152" marT="27432" marB="27432" anchor="ctr">
+                    <a:solidFill>
+                      <a:srgbClr val="FFFFFF"/>
+                    </a:solidFill>
+                  </a:tcPr>
+                </a:tc>
+                <a:tc>
+                  <a:txBody>
+                    <a:bodyPr wrap="square"/>
+                    <a:lstStyle/>
+                    <a:p>
+                      <a:r>
+                        <a:rPr sz="1050">
+                          <a:solidFill>
+                            <a:srgbClr val="222A33"/>
+                          </a:solidFill>
+                          <a:latin typeface="Calibri"/>
+                        </a:rPr>
+                        <a:t/>
+                      </a:r>
+                    </a:p>
+                  </a:txBody>
+                  <a:tcPr marL="73152" marR="73152" marT="27432" marB="27432" anchor="ctr">
+                    <a:solidFill>
+                      <a:srgbClr val="FFFFFF"/>
+                    </a:solidFill>
+                  </a:tcPr>
+                </a:tc>
+              </a:tr>
+              <a:tr h="352698">
+                <a:tc>
+                  <a:txBody>
+                    <a:bodyPr wrap="square"/>
+                    <a:lstStyle/>
+                    <a:p>
+                      <a:r>
+                        <a:rPr sz="1050" b="1">
+                          <a:solidFill>
+                            <a:srgbClr val="222A33"/>
+                          </a:solidFill>
+                          <a:latin typeface="Calibri"/>
+                        </a:rPr>
+                        <a:t>Have you lost…teeth?</a:t>
+                      </a:r>
+                    </a:p>
+                  </a:txBody>
+                  <a:tcPr marL="73152" marR="73152" marT="27432" marB="27432" anchor="ctr">
+                    <a:solidFill>
+                      <a:srgbClr val="EDF1F5"/>
+                    </a:solidFill>
+                  </a:tcPr>
+                </a:tc>
+                <a:tc>
+                  <a:txBody>
+                    <a:bodyPr wrap="square"/>
+                    <a:lstStyle/>
+                    <a:p>
+                      <a:r>
+                        <a:rPr sz="1050">
+                          <a:solidFill>
+                            <a:srgbClr val="222A33"/>
+                          </a:solidFill>
+                          <a:latin typeface="Calibri"/>
+                        </a:rPr>
+                        <a:t>452438775</a:t>
+                      </a:r>
+                    </a:p>
+                  </a:txBody>
+                  <a:tcPr marL="73152" marR="73152" marT="27432" marB="27432" anchor="ctr">
+                    <a:solidFill>
+                      <a:srgbClr val="EDF1F5"/>
+                    </a:solidFill>
+                  </a:tcPr>
+                </a:tc>
+                <a:tc>
+                  <a:txBody>
+                    <a:bodyPr wrap="square"/>
+                    <a:lstStyle/>
+                    <a:p>
+                      <a:r>
+                        <a:rPr sz="1050">
+                          <a:solidFill>
+                            <a:srgbClr val="222A33"/>
+                          </a:solidFill>
+                          <a:latin typeface="Calibri"/>
+                        </a:rPr>
+                        <a:t>Yes, from tooth decay or disease</a:t>
+                      </a:r>
+                    </a:p>
+                  </a:txBody>
+                  <a:tcPr marL="73152" marR="73152" marT="27432" marB="27432" anchor="ctr">
+                    <a:solidFill>
+                      <a:srgbClr val="EDF1F5"/>
+                    </a:solidFill>
+                  </a:tcPr>
+                </a:tc>
+                <a:tc>
+                  <a:txBody>
+                    <a:bodyPr wrap="square"/>
+                    <a:lstStyle/>
+                    <a:p>
+                      <a:r>
+                        <a:rPr sz="1050">
+                          <a:solidFill>
+                            <a:srgbClr val="222A33"/>
+                          </a:solidFill>
+                          <a:latin typeface="Calibri"/>
+                        </a:rPr>
+                        <a:t/>
+                      </a:r>
+                    </a:p>
+                  </a:txBody>
+                  <a:tcPr marL="73152" marR="73152" marT="27432" marB="27432" anchor="ctr">
+                    <a:solidFill>
+                      <a:srgbClr val="EDF1F5"/>
+                    </a:solidFill>
+                  </a:tcPr>
+                </a:tc>
+              </a:tr>
+            </a:tbl>
+          </a:graphicData>
+        </a:graphic>
+      </p:graphicFrame>
+      <p:sp>
+        <p:nvSpPr>
+          <p:cNvPr id="6" name="TextBox 5"/>
+          <p:cNvSpPr txBox="1"/>
+          <p:nvPr/>
+        </p:nvSpPr>
+        <p:spPr>
+          <a:xfrm>
+            <a:off x="457200" y="5852160"/>
+            <a:ext cx="11247120" cy="457200"/>
+          </a:xfrm>
+          <a:prstGeom prst="rect">
+            <a:avLst/>
+          </a:prstGeom>
+          <a:noFill/>
+        </p:spPr>
+        <p:txBody>
+          <a:bodyPr wrap="square">
+            <a:spAutoFit/>
+          </a:bodyPr>
+          <a:lstStyle/>
+          <a:p>
+            <a:pPr algn="l"/>
+            <a:r>
+              <a:rPr sz="1400" b="1" i="0">
+                <a:solidFill>
+                  <a:srgbClr val="CC7D15"/>
+                </a:solidFill>
+                <a:latin typeface="Calibri"/>
+              </a:rPr>
+              <a:t>No decoder ring, no 2,360-column map — the dictionary travels with the data.</a:t>
+            </a:r>
+          </a:p>
+        </p:txBody>
+      </p:sp>
+    </p:spTree>
+  </p:cSld>
+  <p:clrMapOvr>
+    <a:masterClrMapping/>
+  </p:clrMapOvr>
+</p:sld>
+</file>
+
+<file path=ppt/slides/slide18.xml><?xml version="1.0" encoding="utf-8"?>
+<p:sld xmlns:a="http://schemas.openxmlformats.org/drawingml/2006/main" xmlns:p="http://schemas.openxmlformats.org/presentationml/2006/main" xmlns:r="http://schemas.openxmlformats.org/officeDocument/2006/relationships">
+  <p:cSld>
+    <p:spTree>
+      <p:nvGrpSpPr>
+        <p:cNvPr id="1" name=""/>
+        <p:cNvGrpSpPr/>
+        <p:nvPr/>
+      </p:nvGrpSpPr>
+      <p:grpSpPr/>
+      <p:sp>
+        <p:nvSpPr>
+          <p:cNvPr id="2" name="Rectangle 1"/>
+          <p:cNvSpPr/>
+          <p:nvPr/>
+        </p:nvSpPr>
+        <p:spPr>
+          <a:xfrm>
+            <a:off x="0" y="0"/>
+            <a:ext cx="12191695" cy="1051560"/>
+          </a:xfrm>
+          <a:prstGeom prst="rect">
+            <a:avLst/>
+          </a:prstGeom>
+          <a:solidFill>
+            <a:srgbClr val="16324F"/>
+          </a:solidFill>
+          <a:ln>
+            <a:noFill/>
+          </a:ln>
+          <a:effectLst/>
+        </p:spPr>
+        <p:style>
+          <a:lnRef idx="1">
+            <a:schemeClr val="accent1"/>
+          </a:lnRef>
+          <a:fillRef idx="3">
+            <a:schemeClr val="accent1"/>
+          </a:fillRef>
+          <a:effectRef idx="2">
+            <a:schemeClr val="accent1"/>
+          </a:effectRef>
+          <a:fontRef idx="minor">
+            <a:schemeClr val="lt1"/>
+          </a:fontRef>
+        </p:style>
+        <p:txBody>
+          <a:bodyPr rtlCol="0" anchor="ctr" lIns="457200" tIns="109728"/>
+          <a:lstStyle/>
+          <a:p>
+            <a:pPr algn="ctr"/>
+            <a:r>
+              <a:rPr sz="2800" b="1">
+                <a:solidFill>
+                  <a:srgbClr val="FFFFFF"/>
+                </a:solidFill>
+                <a:latin typeface="Calibri"/>
+              </a:rPr>
+              <a:t>Analyzing long format (2/3) — wide is one generic PIVOT away</a:t>
+            </a:r>
+          </a:p>
+          <a:p>
+            <a:r>
+              <a:rPr sz="1300" i="1">
+                <a:solidFill>
+                  <a:srgbClr val="BBD5D7"/>
+                </a:solidFill>
+              </a:rPr>
+              <a:t>Pick your tool — one line, and none of them name a single column</a:t>
+            </a:r>
+          </a:p>
+        </p:txBody>
+      </p:sp>
+      <p:sp>
+        <p:nvSpPr>
+          <p:cNvPr id="3" name="Rectangle 2"/>
+          <p:cNvSpPr/>
+          <p:nvPr/>
+        </p:nvSpPr>
+        <p:spPr>
+          <a:xfrm>
+            <a:off x="0" y="1051560"/>
+            <a:ext cx="12191695" cy="54864"/>
+          </a:xfrm>
+          <a:prstGeom prst="rect">
+            <a:avLst/>
+          </a:prstGeom>
+          <a:solidFill>
+            <a:srgbClr val="2E8B8B"/>
+          </a:solidFill>
+          <a:ln>
+            <a:noFill/>
+          </a:ln>
+          <a:effectLst/>
+        </p:spPr>
+        <p:style>
+          <a:lnRef idx="1">
+            <a:schemeClr val="accent1"/>
+          </a:lnRef>
+          <a:fillRef idx="3">
+            <a:schemeClr val="accent1"/>
+          </a:fillRef>
+          <a:effectRef idx="2">
+            <a:schemeClr val="accent1"/>
+          </a:effectRef>
+          <a:fontRef idx="minor">
+            <a:schemeClr val="lt1"/>
+          </a:fontRef>
+        </p:style>
+        <p:txBody>
+          <a:bodyPr rtlCol="0" anchor="ctr"/>
+          <a:lstStyle/>
+          <a:p>
+            <a:pPr algn="ctr"/>
+          </a:p>
+        </p:txBody>
+      </p:sp>
+      <p:sp>
+        <p:nvSpPr>
+          <p:cNvPr id="4" name="Rectangle 3"/>
+          <p:cNvSpPr/>
+          <p:nvPr/>
+        </p:nvSpPr>
+        <p:spPr>
+          <a:xfrm>
+            <a:off x="457200" y="1261872"/>
+            <a:ext cx="11247120" cy="2697480"/>
+          </a:xfrm>
+          <a:prstGeom prst="rect">
+            <a:avLst/>
+          </a:prstGeom>
+          <a:solidFill>
+            <a:srgbClr val="1E2935"/>
+          </a:solidFill>
+          <a:ln>
+            <a:solidFill>
+              <a:srgbClr val="2E8B8B"/>
+            </a:solidFill>
+          </a:ln>
+          <a:effectLst/>
+        </p:spPr>
+        <p:style>
+          <a:lnRef idx="1">
+            <a:schemeClr val="accent1"/>
+          </a:lnRef>
+          <a:fillRef idx="3">
+            <a:schemeClr val="accent1"/>
+          </a:fillRef>
+          <a:effectRef idx="2">
+            <a:schemeClr val="accent1"/>
+          </a:effectRef>
+          <a:fontRef idx="minor">
+            <a:schemeClr val="lt1"/>
+          </a:fontRef>
+        </p:style>
+        <p:txBody>
+          <a:bodyPr rtlCol="0" anchor="t" wrap="square" lIns="182880" rIns="137160" tIns="109728"/>
+          <a:lstStyle/>
+          <a:p>
+            <a:pPr algn="ctr">
+              <a:lnSpc>
+                <a:spcPct val="100000"/>
+              </a:lnSpc>
+            </a:pPr>
+            <a:r>
+              <a:rPr sz="1200">
+                <a:solidFill>
+                  <a:srgbClr val="8BA6C0"/>
+                </a:solidFill>
+                <a:latin typeface="Courier New"/>
+              </a:rPr>
+              <a:t>-- SQL (DuckDB) — column names come from the DATA, not from you</a:t>
+            </a:r>
+          </a:p>
+          <a:p>
+            <a:pPr>
+              <a:lnSpc>
+                <a:spcPct val="100000"/>
+              </a:lnSpc>
+            </a:pPr>
+            <a:r>
+              <a:rPr sz="1200">
+                <a:solidFill>
+                  <a:srgbClr val="E6EDF3"/>
+                </a:solidFill>
+                <a:latin typeface="Courier New"/>
+              </a:rPr>
+              <a:t>PIVOT (FROM v_long SELECT connect_id, question_text, answer</a:t>
+            </a:r>
+          </a:p>
+          <a:p>
+            <a:pPr>
+              <a:lnSpc>
+                <a:spcPct val="100000"/>
+              </a:lnSpc>
+            </a:pPr>
+            <a:r>
+              <a:rPr sz="1200">
+                <a:solidFill>
+                  <a:srgbClr val="E6EDF3"/>
+                </a:solidFill>
+                <a:latin typeface="Courier New"/>
+              </a:rPr>
+              <a:t>       WHERE question_type &lt;&gt; 'multi_select')</a:t>
+            </a:r>
+          </a:p>
+          <a:p>
+            <a:pPr>
+              <a:lnSpc>
+                <a:spcPct val="100000"/>
+              </a:lnSpc>
+            </a:pPr>
+            <a:r>
+              <a:rPr sz="1200">
+                <a:solidFill>
+                  <a:srgbClr val="E6EDF3"/>
+                </a:solidFill>
+                <a:latin typeface="Courier New"/>
+              </a:rPr>
+              <a:t>  ON question_text USING any_value(answer);</a:t>
+            </a:r>
+          </a:p>
+          <a:p>
+            <a:pPr>
+              <a:lnSpc>
+                <a:spcPct val="100000"/>
+              </a:lnSpc>
+            </a:pPr>
+            <a:r>
+              <a:rPr sz="1200">
+                <a:solidFill>
+                  <a:srgbClr val="E6EDF3"/>
+                </a:solidFill>
+                <a:latin typeface="Courier New"/>
+              </a:rPr>
+              <a:t> </a:t>
+            </a:r>
+          </a:p>
+          <a:p>
+            <a:pPr>
+              <a:lnSpc>
+                <a:spcPct val="100000"/>
+              </a:lnSpc>
+            </a:pPr>
+            <a:r>
+              <a:rPr sz="1200">
+                <a:solidFill>
+                  <a:srgbClr val="8BA6C0"/>
+                </a:solidFill>
+                <a:latin typeface="Courier New"/>
+              </a:rPr>
+              <a:t># Python (pandas)</a:t>
+            </a:r>
+          </a:p>
+          <a:p>
+            <a:pPr>
+              <a:lnSpc>
+                <a:spcPct val="100000"/>
+              </a:lnSpc>
+            </a:pPr>
+            <a:r>
+              <a:rPr sz="1200">
+                <a:solidFill>
+                  <a:srgbClr val="E6EDF3"/>
+                </a:solidFill>
+                <a:latin typeface="Courier New"/>
+              </a:rPr>
+              <a:t>long.pivot(index='connect_id', columns='question_text', values='answer')</a:t>
+            </a:r>
+          </a:p>
+          <a:p>
+            <a:pPr>
+              <a:lnSpc>
+                <a:spcPct val="100000"/>
+              </a:lnSpc>
+            </a:pPr>
+            <a:r>
+              <a:rPr sz="1200">
+                <a:solidFill>
+                  <a:srgbClr val="E6EDF3"/>
+                </a:solidFill>
+                <a:latin typeface="Courier New"/>
+              </a:rPr>
+              <a:t> </a:t>
+            </a:r>
+          </a:p>
+          <a:p>
+            <a:pPr>
+              <a:lnSpc>
+                <a:spcPct val="100000"/>
+              </a:lnSpc>
+            </a:pPr>
+            <a:r>
+              <a:rPr sz="1200">
+                <a:solidFill>
+                  <a:srgbClr val="8BA6C0"/>
+                </a:solidFill>
+                <a:latin typeface="Courier New"/>
+              </a:rPr>
+              <a:t># R (tidyr)</a:t>
+            </a:r>
+          </a:p>
+          <a:p>
+            <a:pPr>
+              <a:lnSpc>
+                <a:spcPct val="100000"/>
+              </a:lnSpc>
+            </a:pPr>
+            <a:r>
+              <a:rPr sz="1200">
+                <a:solidFill>
+                  <a:srgbClr val="E6EDF3"/>
+                </a:solidFill>
+                <a:latin typeface="Courier New"/>
+              </a:rPr>
+              <a:t>pivot_wider(long, id_cols=connect_id, names_from=question_text, values_from=answer)</a:t>
+            </a:r>
+          </a:p>
+        </p:txBody>
+      </p:sp>
+      <p:graphicFrame>
+        <p:nvGraphicFramePr>
+          <p:cNvPr id="5" name="Table 4"/>
+          <p:cNvGraphicFramePr>
+            <a:graphicFrameLocks noGrp="1"/>
+          </p:cNvGraphicFramePr>
+          <p:nvPr/>
+        </p:nvGraphicFramePr>
+        <p:xfrm>
+          <a:off x="1463040" y="4160520"/>
+          <a:ext cx="9235440" cy="1554480"/>
+        </p:xfrm>
+        <a:graphic>
+          <a:graphicData uri="http://schemas.openxmlformats.org/drawingml/2006/table">
+            <a:tbl>
+              <a:tblPr firstRow="1" bandRow="1">
+                <a:tableStyleId>{5C22544A-7EE6-4342-B048-85BDC9FD1C3A}</a:tableStyleId>
+              </a:tblPr>
+              <a:tblGrid>
+                <a:gridCol w="1371600"/>
+                <a:gridCol w="914400"/>
+                <a:gridCol w="3931920"/>
+                <a:gridCol w="1371600"/>
+                <a:gridCol w="1645920"/>
+              </a:tblGrid>
+              <a:tr h="259080">
+                <a:tc>
+                  <a:txBody>
+                    <a:bodyPr wrap="square"/>
+                    <a:lstStyle/>
+                    <a:p>
+                      <a:r>
+                        <a:rPr b="1" sz="1150">
+                          <a:solidFill>
+                            <a:srgbClr val="FFFFFF"/>
+                          </a:solidFill>
+                          <a:latin typeface="Calibri"/>
+                        </a:rPr>
+                        <a:t>connect_id</a:t>
+                      </a:r>
+                    </a:p>
+                  </a:txBody>
+                  <a:tcPr marL="73152" marR="73152" marT="27432" marB="27432" anchor="ctr">
+                    <a:solidFill>
+                      <a:srgbClr val="16324F"/>
+                    </a:solidFill>
+                  </a:tcPr>
+                </a:tc>
+                <a:tc>
+                  <a:txBody>
+                    <a:bodyPr wrap="square"/>
+                    <a:lstStyle/>
+                    <a:p>
+                      <a:r>
+                        <a:rPr b="1" sz="1150">
+                          <a:solidFill>
+                            <a:srgbClr val="FFFFFF"/>
+                          </a:solidFill>
+                          <a:latin typeface="Calibri"/>
+                        </a:rPr>
+                        <a:t>Age</a:t>
+                      </a:r>
+                    </a:p>
+                  </a:txBody>
+                  <a:tcPr marL="73152" marR="73152" marT="27432" marB="27432" anchor="ctr">
+                    <a:solidFill>
+                      <a:srgbClr val="16324F"/>
+                    </a:solidFill>
+                  </a:tcPr>
+                </a:tc>
+                <a:tc>
+                  <a:txBody>
+                    <a:bodyPr wrap="square"/>
+                    <a:lstStyle/>
+                    <a:p>
+                      <a:r>
+                        <a:rPr b="1" sz="1150">
+                          <a:solidFill>
+                            <a:srgbClr val="FFFFFF"/>
+                          </a:solidFill>
+                          <a:latin typeface="Calibri"/>
+                        </a:rPr>
+                        <a:t>Education</a:t>
+                      </a:r>
+                    </a:p>
+                  </a:txBody>
+                  <a:tcPr marL="73152" marR="73152" marT="27432" marB="27432" anchor="ctr">
+                    <a:solidFill>
+                      <a:srgbClr val="16324F"/>
+                    </a:solidFill>
+                  </a:tcPr>
+                </a:tc>
+                <a:tc>
+                  <a:txBody>
+                    <a:bodyPr wrap="square"/>
+                    <a:lstStyle/>
+                    <a:p>
+                      <a:r>
+                        <a:rPr b="1" sz="1150">
+                          <a:solidFill>
+                            <a:srgbClr val="FFFFFF"/>
+                          </a:solidFill>
+                          <a:latin typeface="Calibri"/>
+                        </a:rPr>
+                        <a:t>Sex</a:t>
+                      </a:r>
+                    </a:p>
+                  </a:txBody>
+                  <a:tcPr marL="73152" marR="73152" marT="27432" marB="27432" anchor="ctr">
+                    <a:solidFill>
+                      <a:srgbClr val="16324F"/>
+                    </a:solidFill>
+                  </a:tcPr>
+                </a:tc>
+                <a:tc>
+                  <a:txBody>
+                    <a:bodyPr wrap="square"/>
+                    <a:lstStyle/>
+                    <a:p>
+                      <a:r>
+                        <a:rPr b="1" sz="1150">
+                          <a:solidFill>
+                            <a:srgbClr val="FFFFFF"/>
+                          </a:solidFill>
+                          <a:latin typeface="Calibri"/>
+                        </a:rPr>
+                        <a:t>Smoking Status</a:t>
+                      </a:r>
+                    </a:p>
+                  </a:txBody>
+                  <a:tcPr marL="73152" marR="73152" marT="27432" marB="27432" anchor="ctr">
+                    <a:solidFill>
+                      <a:srgbClr val="16324F"/>
+                    </a:solidFill>
+                  </a:tcPr>
+                </a:tc>
+              </a:tr>
+              <a:tr h="259080">
+                <a:tc>
+                  <a:txBody>
+                    <a:bodyPr wrap="square"/>
+                    <a:lstStyle/>
+                    <a:p>
+                      <a:r>
+                        <a:rPr sz="1150" b="1">
+                          <a:solidFill>
+                            <a:srgbClr val="222A33"/>
+                          </a:solidFill>
+                          <a:latin typeface="Calibri"/>
+                        </a:rPr>
+                        <a:t>1001</a:t>
+                      </a:r>
+                    </a:p>
+                  </a:txBody>
+                  <a:tcPr marL="73152" marR="73152" marT="27432" marB="27432" anchor="ctr">
+                    <a:solidFill>
+                      <a:srgbClr val="FFFFFF"/>
+                    </a:solidFill>
+                  </a:tcPr>
+                </a:tc>
+                <a:tc>
+                  <a:txBody>
+                    <a:bodyPr wrap="square"/>
+                    <a:lstStyle/>
+                    <a:p>
+                      <a:r>
+                        <a:rPr sz="1150">
+                          <a:solidFill>
+                            <a:srgbClr val="222A33"/>
+                          </a:solidFill>
+                          <a:latin typeface="Calibri"/>
+                        </a:rPr>
+                        <a:t>47</a:t>
+                      </a:r>
+                    </a:p>
+                  </a:txBody>
+                  <a:tcPr marL="73152" marR="73152" marT="27432" marB="27432" anchor="ctr">
+                    <a:solidFill>
+                      <a:srgbClr val="FFFFFF"/>
+                    </a:solidFill>
+                  </a:tcPr>
+                </a:tc>
+                <a:tc>
+                  <a:txBody>
+                    <a:bodyPr wrap="square"/>
+                    <a:lstStyle/>
+                    <a:p>
+                      <a:r>
+                        <a:rPr sz="1150">
+                          <a:solidFill>
+                            <a:srgbClr val="222A33"/>
+                          </a:solidFill>
+                          <a:latin typeface="Calibri"/>
+                        </a:rPr>
+                        <a:t>Bachelor's Degree</a:t>
+                      </a:r>
+                    </a:p>
+                  </a:txBody>
+                  <a:tcPr marL="73152" marR="73152" marT="27432" marB="27432" anchor="ctr">
+                    <a:solidFill>
+                      <a:srgbClr val="FFFFFF"/>
+                    </a:solidFill>
+                  </a:tcPr>
+                </a:tc>
+                <a:tc>
+                  <a:txBody>
+                    <a:bodyPr wrap="square"/>
+                    <a:lstStyle/>
+                    <a:p>
+                      <a:r>
+                        <a:rPr sz="1150">
+                          <a:solidFill>
+                            <a:srgbClr val="222A33"/>
+                          </a:solidFill>
+                          <a:latin typeface="Calibri"/>
+                        </a:rPr>
+                        <a:t>Female</a:t>
+                      </a:r>
+                    </a:p>
+                  </a:txBody>
+                  <a:tcPr marL="73152" marR="73152" marT="27432" marB="27432" anchor="ctr">
+                    <a:solidFill>
+                      <a:srgbClr val="FFFFFF"/>
+                    </a:solidFill>
+                  </a:tcPr>
+                </a:tc>
+                <a:tc>
+                  <a:txBody>
+                    <a:bodyPr wrap="square"/>
+                    <a:lstStyle/>
+                    <a:p>
+                      <a:r>
+                        <a:rPr sz="1150">
+                          <a:solidFill>
+                            <a:srgbClr val="222A33"/>
+                          </a:solidFill>
+                          <a:latin typeface="Calibri"/>
+                        </a:rPr>
+                        <a:t>Former</a:t>
+                      </a:r>
+                    </a:p>
+                  </a:txBody>
+                  <a:tcPr marL="73152" marR="73152" marT="27432" marB="27432" anchor="ctr">
+                    <a:solidFill>
+                      <a:srgbClr val="FFFFFF"/>
+                    </a:solidFill>
+                  </a:tcPr>
+                </a:tc>
+              </a:tr>
+              <a:tr h="259080">
+                <a:tc>
+                  <a:txBody>
+                    <a:bodyPr wrap="square"/>
+                    <a:lstStyle/>
+                    <a:p>
+                      <a:r>
+                        <a:rPr sz="1150" b="1">
+                          <a:solidFill>
+                            <a:srgbClr val="222A33"/>
+                          </a:solidFill>
+                          <a:latin typeface="Calibri"/>
+                        </a:rPr>
+                        <a:t>1002</a:t>
+                      </a:r>
+                    </a:p>
+                  </a:txBody>
+                  <a:tcPr marL="73152" marR="73152" marT="27432" marB="27432" anchor="ctr">
+                    <a:solidFill>
+                      <a:srgbClr val="EDF1F5"/>
+                    </a:solidFill>
+                  </a:tcPr>
+                </a:tc>
+                <a:tc>
+                  <a:txBody>
+                    <a:bodyPr wrap="square"/>
+                    <a:lstStyle/>
+                    <a:p>
+                      <a:r>
+                        <a:rPr sz="1150">
+                          <a:solidFill>
+                            <a:srgbClr val="222A33"/>
+                          </a:solidFill>
+                          <a:latin typeface="Calibri"/>
+                        </a:rPr>
+                        <a:t>62</a:t>
+                      </a:r>
+                    </a:p>
+                  </a:txBody>
+                  <a:tcPr marL="73152" marR="73152" marT="27432" marB="27432" anchor="ctr">
+                    <a:solidFill>
+                      <a:srgbClr val="EDF1F5"/>
+                    </a:solidFill>
+                  </a:tcPr>
+                </a:tc>
+                <a:tc>
+                  <a:txBody>
+                    <a:bodyPr wrap="square"/>
+                    <a:lstStyle/>
+                    <a:p>
+                      <a:r>
+                        <a:rPr sz="1150">
+                          <a:solidFill>
+                            <a:srgbClr val="222A33"/>
+                          </a:solidFill>
+                          <a:latin typeface="Calibri"/>
+                        </a:rPr>
+                        <a:t>High School Graduate or GED</a:t>
+                      </a:r>
+                    </a:p>
+                  </a:txBody>
+                  <a:tcPr marL="73152" marR="73152" marT="27432" marB="27432" anchor="ctr">
+                    <a:solidFill>
+                      <a:srgbClr val="EDF1F5"/>
+                    </a:solidFill>
+                  </a:tcPr>
+                </a:tc>
+                <a:tc>
+                  <a:txBody>
+                    <a:bodyPr wrap="square"/>
+                    <a:lstStyle/>
+                    <a:p>
+                      <a:r>
+                        <a:rPr sz="1150">
+                          <a:solidFill>
+                            <a:srgbClr val="222A33"/>
+                          </a:solidFill>
+                          <a:latin typeface="Calibri"/>
+                        </a:rPr>
+                        <a:t>Male</a:t>
+                      </a:r>
+                    </a:p>
+                  </a:txBody>
+                  <a:tcPr marL="73152" marR="73152" marT="27432" marB="27432" anchor="ctr">
+                    <a:solidFill>
+                      <a:srgbClr val="EDF1F5"/>
+                    </a:solidFill>
+                  </a:tcPr>
+                </a:tc>
+                <a:tc>
+                  <a:txBody>
+                    <a:bodyPr wrap="square"/>
+                    <a:lstStyle/>
+                    <a:p>
+                      <a:r>
+                        <a:rPr sz="1150">
+                          <a:solidFill>
+                            <a:srgbClr val="222A33"/>
+                          </a:solidFill>
+                          <a:latin typeface="Calibri"/>
+                        </a:rPr>
+                        <a:t>Current</a:t>
+                      </a:r>
+                    </a:p>
+                  </a:txBody>
+                  <a:tcPr marL="73152" marR="73152" marT="27432" marB="27432" anchor="ctr">
+                    <a:solidFill>
+                      <a:srgbClr val="EDF1F5"/>
+                    </a:solidFill>
+                  </a:tcPr>
+                </a:tc>
+              </a:tr>
+              <a:tr h="259080">
+                <a:tc>
+                  <a:txBody>
+                    <a:bodyPr wrap="square"/>
+                    <a:lstStyle/>
+                    <a:p>
+                      <a:r>
+                        <a:rPr sz="1150" b="1">
+                          <a:solidFill>
+                            <a:srgbClr val="222A33"/>
+                          </a:solidFill>
+                          <a:latin typeface="Calibri"/>
+                        </a:rPr>
+                        <a:t>1003</a:t>
+                      </a:r>
+                    </a:p>
+                  </a:txBody>
+                  <a:tcPr marL="73152" marR="73152" marT="27432" marB="27432" anchor="ctr">
+                    <a:solidFill>
+                      <a:srgbClr val="FFFFFF"/>
+                    </a:solidFill>
+                  </a:tcPr>
+                </a:tc>
+                <a:tc>
+                  <a:txBody>
+                    <a:bodyPr wrap="square"/>
+                    <a:lstStyle/>
+                    <a:p>
+                      <a:r>
+                        <a:rPr sz="1150">
+                          <a:solidFill>
+                            <a:srgbClr val="222A33"/>
+                          </a:solidFill>
+                          <a:latin typeface="Calibri"/>
+                        </a:rPr>
+                        <a:t>55</a:t>
+                      </a:r>
+                    </a:p>
+                  </a:txBody>
+                  <a:tcPr marL="73152" marR="73152" marT="27432" marB="27432" anchor="ctr">
+                    <a:solidFill>
+                      <a:srgbClr val="FFFFFF"/>
+                    </a:solidFill>
+                  </a:tcPr>
+                </a:tc>
+                <a:tc>
+                  <a:txBody>
+                    <a:bodyPr wrap="square"/>
+                    <a:lstStyle/>
+                    <a:p>
+                      <a:r>
+                        <a:rPr sz="1150">
+                          <a:solidFill>
+                            <a:srgbClr val="222A33"/>
+                          </a:solidFill>
+                          <a:latin typeface="Calibri"/>
+                        </a:rPr>
+                        <a:t>Advanced Degree</a:t>
+                      </a:r>
+                    </a:p>
+                  </a:txBody>
+                  <a:tcPr marL="73152" marR="73152" marT="27432" marB="27432" anchor="ctr">
+                    <a:solidFill>
+                      <a:srgbClr val="FFFFFF"/>
+                    </a:solidFill>
+                  </a:tcPr>
+                </a:tc>
+                <a:tc>
+                  <a:txBody>
+                    <a:bodyPr wrap="square"/>
+                    <a:lstStyle/>
+                    <a:p>
+                      <a:r>
+                        <a:rPr sz="1150">
+                          <a:solidFill>
+                            <a:srgbClr val="222A33"/>
+                          </a:solidFill>
+                          <a:latin typeface="Calibri"/>
+                        </a:rPr>
+                        <a:t>Female</a:t>
+                      </a:r>
+                    </a:p>
+                  </a:txBody>
+                  <a:tcPr marL="73152" marR="73152" marT="27432" marB="27432" anchor="ctr">
+                    <a:solidFill>
+                      <a:srgbClr val="FFFFFF"/>
+                    </a:solidFill>
+                  </a:tcPr>
+                </a:tc>
+                <a:tc>
+                  <a:txBody>
+                    <a:bodyPr wrap="square"/>
+                    <a:lstStyle/>
+                    <a:p>
+                      <a:r>
+                        <a:rPr sz="1150">
+                          <a:solidFill>
+                            <a:srgbClr val="222A33"/>
+                          </a:solidFill>
+                          <a:latin typeface="Calibri"/>
+                        </a:rPr>
+                        <a:t>Never</a:t>
+                      </a:r>
+                    </a:p>
+                  </a:txBody>
+                  <a:tcPr marL="73152" marR="73152" marT="27432" marB="27432" anchor="ctr">
+                    <a:solidFill>
+                      <a:srgbClr val="FFFFFF"/>
+                    </a:solidFill>
+                  </a:tcPr>
+                </a:tc>
+              </a:tr>
+              <a:tr h="259080">
+                <a:tc>
+                  <a:txBody>
+                    <a:bodyPr wrap="square"/>
+                    <a:lstStyle/>
+                    <a:p>
+                      <a:r>
+                        <a:rPr sz="1150" b="1">
+                          <a:solidFill>
+                            <a:srgbClr val="222A33"/>
+                          </a:solidFill>
+                          <a:latin typeface="Calibri"/>
+                        </a:rPr>
+                        <a:t>1004</a:t>
+                      </a:r>
+                    </a:p>
+                  </a:txBody>
+                  <a:tcPr marL="73152" marR="73152" marT="27432" marB="27432" anchor="ctr">
+                    <a:solidFill>
+                      <a:srgbClr val="EDF1F5"/>
+                    </a:solidFill>
+                  </a:tcPr>
+                </a:tc>
+                <a:tc>
+                  <a:txBody>
+                    <a:bodyPr wrap="square"/>
+                    <a:lstStyle/>
+                    <a:p>
+                      <a:r>
+                        <a:rPr sz="1150">
+                          <a:solidFill>
+                            <a:srgbClr val="222A33"/>
+                          </a:solidFill>
+                          <a:latin typeface="Calibri"/>
+                        </a:rPr>
+                        <a:t>39</a:t>
+                      </a:r>
+                    </a:p>
+                  </a:txBody>
+                  <a:tcPr marL="73152" marR="73152" marT="27432" marB="27432" anchor="ctr">
+                    <a:solidFill>
+                      <a:srgbClr val="EDF1F5"/>
+                    </a:solidFill>
+                  </a:tcPr>
+                </a:tc>
+                <a:tc>
+                  <a:txBody>
+                    <a:bodyPr wrap="square"/>
+                    <a:lstStyle/>
+                    <a:p>
+                      <a:r>
+                        <a:rPr sz="1150">
+                          <a:solidFill>
+                            <a:srgbClr val="222A33"/>
+                          </a:solidFill>
+                          <a:latin typeface="Calibri"/>
+                        </a:rPr>
+                        <a:t>Bachelor's Degree</a:t>
+                      </a:r>
+                    </a:p>
+                  </a:txBody>
+                  <a:tcPr marL="73152" marR="73152" marT="27432" marB="27432" anchor="ctr">
+                    <a:solidFill>
+                      <a:srgbClr val="EDF1F5"/>
+                    </a:solidFill>
+                  </a:tcPr>
+                </a:tc>
+                <a:tc>
+                  <a:txBody>
+                    <a:bodyPr wrap="square"/>
+                    <a:lstStyle/>
+                    <a:p>
+                      <a:r>
+                        <a:rPr sz="1150">
+                          <a:solidFill>
+                            <a:srgbClr val="222A33"/>
+                          </a:solidFill>
+                          <a:latin typeface="Calibri"/>
+                        </a:rPr>
+                        <a:t>Male</a:t>
+                      </a:r>
+                    </a:p>
+                  </a:txBody>
+                  <a:tcPr marL="73152" marR="73152" marT="27432" marB="27432" anchor="ctr">
+                    <a:solidFill>
+                      <a:srgbClr val="EDF1F5"/>
+                    </a:solidFill>
+                  </a:tcPr>
+                </a:tc>
+                <a:tc>
+                  <a:txBody>
+                    <a:bodyPr wrap="square"/>
+                    <a:lstStyle/>
+                    <a:p>
+                      <a:r>
+                        <a:rPr sz="1150">
+                          <a:solidFill>
+                            <a:srgbClr val="222A33"/>
+                          </a:solidFill>
+                          <a:latin typeface="Calibri"/>
+                        </a:rPr>
+                        <a:t>Never</a:t>
+                      </a:r>
+                    </a:p>
+                  </a:txBody>
+                  <a:tcPr marL="73152" marR="73152" marT="27432" marB="27432" anchor="ctr">
+                    <a:solidFill>
+                      <a:srgbClr val="EDF1F5"/>
+                    </a:solidFill>
+                  </a:tcPr>
+                </a:tc>
+              </a:tr>
+              <a:tr h="259080">
+                <a:tc>
+                  <a:txBody>
+                    <a:bodyPr wrap="square"/>
+                    <a:lstStyle/>
+                    <a:p>
+                      <a:r>
+                        <a:rPr sz="1150" b="1">
+                          <a:solidFill>
+                            <a:srgbClr val="222A33"/>
+                          </a:solidFill>
+                          <a:latin typeface="Calibri"/>
+                        </a:rPr>
+                        <a:t>1005</a:t>
+                      </a:r>
+                    </a:p>
+                  </a:txBody>
+                  <a:tcPr marL="73152" marR="73152" marT="27432" marB="27432" anchor="ctr">
+                    <a:solidFill>
+                      <a:srgbClr val="FFFFFF"/>
+                    </a:solidFill>
+                  </a:tcPr>
+                </a:tc>
+                <a:tc>
+                  <a:txBody>
+                    <a:bodyPr wrap="square"/>
+                    <a:lstStyle/>
+                    <a:p>
+                      <a:r>
+                        <a:rPr sz="1150">
+                          <a:solidFill>
+                            <a:srgbClr val="222A33"/>
+                          </a:solidFill>
+                          <a:latin typeface="Calibri"/>
+                        </a:rPr>
+                        <a:t>71</a:t>
+                      </a:r>
+                    </a:p>
+                  </a:txBody>
+                  <a:tcPr marL="73152" marR="73152" marT="27432" marB="27432" anchor="ctr">
+                    <a:solidFill>
+                      <a:srgbClr val="FFFFFF"/>
+                    </a:solidFill>
+                  </a:tcPr>
+                </a:tc>
+                <a:tc>
+                  <a:txBody>
+                    <a:bodyPr wrap="square"/>
+                    <a:lstStyle/>
+                    <a:p>
+                      <a:r>
+                        <a:rPr sz="1150">
+                          <a:solidFill>
+                            <a:srgbClr val="222A33"/>
+                          </a:solidFill>
+                          <a:latin typeface="Calibri"/>
+                        </a:rPr>
+                        <a:t>High School Graduate or GED</a:t>
+                      </a:r>
+                    </a:p>
+                  </a:txBody>
+                  <a:tcPr marL="73152" marR="73152" marT="27432" marB="27432" anchor="ctr">
+                    <a:solidFill>
+                      <a:srgbClr val="FFFFFF"/>
+                    </a:solidFill>
+                  </a:tcPr>
+                </a:tc>
+                <a:tc>
+                  <a:txBody>
+                    <a:bodyPr wrap="square"/>
+                    <a:lstStyle/>
+                    <a:p>
+                      <a:r>
+                        <a:rPr sz="1150">
+                          <a:solidFill>
+                            <a:srgbClr val="222A33"/>
+                          </a:solidFill>
+                          <a:latin typeface="Calibri"/>
+                        </a:rPr>
+                        <a:t>Female</a:t>
+                      </a:r>
+                    </a:p>
+                  </a:txBody>
+                  <a:tcPr marL="73152" marR="73152" marT="27432" marB="27432" anchor="ctr">
+                    <a:solidFill>
+                      <a:srgbClr val="FFFFFF"/>
+                    </a:solidFill>
+                  </a:tcPr>
+                </a:tc>
+                <a:tc>
+                  <a:txBody>
+                    <a:bodyPr wrap="square"/>
+                    <a:lstStyle/>
+                    <a:p>
+                      <a:r>
+                        <a:rPr sz="1150">
+                          <a:solidFill>
+                            <a:srgbClr val="222A33"/>
+                          </a:solidFill>
+                          <a:latin typeface="Calibri"/>
+                        </a:rPr>
+                        <a:t>Former</a:t>
+                      </a:r>
+                    </a:p>
+                  </a:txBody>
+                  <a:tcPr marL="73152" marR="73152" marT="27432" marB="27432" anchor="ctr">
+                    <a:solidFill>
+                      <a:srgbClr val="FFFFFF"/>
+                    </a:solidFill>
+                  </a:tcPr>
+                </a:tc>
+              </a:tr>
+            </a:tbl>
+          </a:graphicData>
+        </a:graphic>
+      </p:graphicFrame>
+      <p:sp>
+        <p:nvSpPr>
+          <p:cNvPr id="6" name="TextBox 5"/>
+          <p:cNvSpPr txBox="1"/>
+          <p:nvPr/>
+        </p:nvSpPr>
+        <p:spPr>
+          <a:xfrm>
+            <a:off x="457200" y="5852160"/>
+            <a:ext cx="11247120" cy="457200"/>
+          </a:xfrm>
+          <a:prstGeom prst="rect">
+            <a:avLst/>
+          </a:prstGeom>
+          <a:noFill/>
+        </p:spPr>
+        <p:txBody>
+          <a:bodyPr wrap="square">
+            <a:spAutoFit/>
+          </a:bodyPr>
+          <a:lstStyle/>
+          <a:p>
+            <a:pPr algn="l"/>
+            <a:r>
+              <a:rPr sz="1350" b="1" i="0">
+                <a:solidFill>
+                  <a:srgbClr val="CC7D15"/>
+                </a:solidFill>
+                <a:latin typeface="Calibri"/>
+              </a:rPr>
+              <a:t>Column names come from the data, not from you — add a question, get a new column. Wrap it once as get_wide(survey) and every team reuses it.</a:t>
+            </a:r>
+          </a:p>
+        </p:txBody>
+      </p:sp>
+      <p:sp>
+        <p:nvSpPr>
+          <p:cNvPr id="7" name="TextBox 6"/>
+          <p:cNvSpPr txBox="1"/>
+          <p:nvPr/>
+        </p:nvSpPr>
+        <p:spPr>
+          <a:xfrm>
+            <a:off x="457200" y="6327648"/>
+            <a:ext cx="11247120" cy="365760"/>
+          </a:xfrm>
+          <a:prstGeom prst="rect">
+            <a:avLst/>
+          </a:prstGeom>
+          <a:noFill/>
+        </p:spPr>
+        <p:txBody>
+          <a:bodyPr wrap="square">
+            <a:spAutoFit/>
+          </a:bodyPr>
+          <a:lstStyle/>
+          <a:p>
+            <a:pPr algn="l"/>
+            <a:r>
+              <a:rPr sz="1050" b="0" i="1">
+                <a:solidFill>
+                  <a:srgbClr val="5A636E"/>
+                </a:solidFill>
+                <a:latin typeface="Calibri"/>
+              </a:rPr>
+              <a:t>pandas &amp; tidyr discover columns automatically; BigQuery's PIVOT lists the values (or generate them with dynamic SQL). `long` = the single-value answers.</a:t>
+            </a:r>
+          </a:p>
+        </p:txBody>
+      </p:sp>
+    </p:spTree>
+  </p:cSld>
+  <p:clrMapOvr>
+    <a:masterClrMapping/>
+  </p:clrMapOvr>
+</p:sld>
+</file>
+
+<file path=ppt/slides/slide19.xml><?xml version="1.0" encoding="utf-8"?>
+<p:sld xmlns:a="http://schemas.openxmlformats.org/drawingml/2006/main" xmlns:p="http://schemas.openxmlformats.org/presentationml/2006/main" xmlns:r="http://schemas.openxmlformats.org/officeDocument/2006/relationships">
+  <p:cSld>
+    <p:spTree>
+      <p:nvGrpSpPr>
+        <p:cNvPr id="1" name=""/>
+        <p:cNvGrpSpPr/>
+        <p:nvPr/>
+      </p:nvGrpSpPr>
+      <p:grpSpPr/>
+      <p:sp>
+        <p:nvSpPr>
+          <p:cNvPr id="2" name="Rectangle 1"/>
+          <p:cNvSpPr/>
+          <p:nvPr/>
+        </p:nvSpPr>
+        <p:spPr>
+          <a:xfrm>
+            <a:off x="0" y="0"/>
+            <a:ext cx="12191695" cy="1051560"/>
+          </a:xfrm>
+          <a:prstGeom prst="rect">
+            <a:avLst/>
+          </a:prstGeom>
+          <a:solidFill>
+            <a:srgbClr val="16324F"/>
+          </a:solidFill>
+          <a:ln>
+            <a:noFill/>
+          </a:ln>
+          <a:effectLst/>
+        </p:spPr>
+        <p:style>
+          <a:lnRef idx="1">
+            <a:schemeClr val="accent1"/>
+          </a:lnRef>
+          <a:fillRef idx="3">
+            <a:schemeClr val="accent1"/>
+          </a:fillRef>
+          <a:effectRef idx="2">
+            <a:schemeClr val="accent1"/>
+          </a:effectRef>
+          <a:fontRef idx="minor">
+            <a:schemeClr val="lt1"/>
+          </a:fontRef>
+        </p:style>
+        <p:txBody>
+          <a:bodyPr rtlCol="0" anchor="ctr" lIns="457200" tIns="109728"/>
+          <a:lstStyle/>
+          <a:p>
+            <a:pPr algn="ctr"/>
+            <a:r>
+              <a:rPr sz="2800" b="1">
+                <a:solidFill>
+                  <a:srgbClr val="FFFFFF"/>
+                </a:solidFill>
+                <a:latin typeface="Calibri"/>
+              </a:rPr>
+              <a:t>Analyzing long format (3/3) — counts are a simple GROUP BY</a:t>
+            </a:r>
+          </a:p>
+          <a:p>
+            <a:r>
+              <a:rPr sz="1300" i="1">
+                <a:solidFill>
+                  <a:srgbClr val="BBD5D7"/>
+                </a:solidFill>
+              </a:rPr>
+              <a:t>And select-all gets *easier*: one group-by, no summing 0/1 columns</a:t>
+            </a:r>
+          </a:p>
+        </p:txBody>
+      </p:sp>
+      <p:sp>
+        <p:nvSpPr>
+          <p:cNvPr id="3" name="Rectangle 2"/>
+          <p:cNvSpPr/>
+          <p:nvPr/>
+        </p:nvSpPr>
+        <p:spPr>
+          <a:xfrm>
+            <a:off x="0" y="1051560"/>
+            <a:ext cx="12191695" cy="54864"/>
+          </a:xfrm>
+          <a:prstGeom prst="rect">
+            <a:avLst/>
+          </a:prstGeom>
+          <a:solidFill>
+            <a:srgbClr val="2E8B8B"/>
+          </a:solidFill>
+          <a:ln>
+            <a:noFill/>
+          </a:ln>
+          <a:effectLst/>
+        </p:spPr>
+        <p:style>
+          <a:lnRef idx="1">
+            <a:schemeClr val="accent1"/>
+          </a:lnRef>
+          <a:fillRef idx="3">
+            <a:schemeClr val="accent1"/>
+          </a:fillRef>
+          <a:effectRef idx="2">
+            <a:schemeClr val="accent1"/>
+          </a:effectRef>
+          <a:fontRef idx="minor">
+            <a:schemeClr val="lt1"/>
+          </a:fontRef>
+        </p:style>
+        <p:txBody>
+          <a:bodyPr rtlCol="0" anchor="ctr"/>
+          <a:lstStyle/>
+          <a:p>
+            <a:pPr algn="ctr"/>
+          </a:p>
+        </p:txBody>
+      </p:sp>
+      <p:sp>
+        <p:nvSpPr>
+          <p:cNvPr id="4" name="Rectangle 3"/>
+          <p:cNvSpPr/>
+          <p:nvPr/>
+        </p:nvSpPr>
+        <p:spPr>
+          <a:xfrm>
+            <a:off x="457200" y="1371600"/>
+            <a:ext cx="5486400" cy="2194560"/>
+          </a:xfrm>
+          <a:prstGeom prst="rect">
+            <a:avLst/>
+          </a:prstGeom>
+          <a:solidFill>
+            <a:srgbClr val="1E2935"/>
+          </a:solidFill>
+          <a:ln>
+            <a:solidFill>
+              <a:srgbClr val="2E8B8B"/>
+            </a:solidFill>
+          </a:ln>
+          <a:effectLst/>
+        </p:spPr>
+        <p:style>
+          <a:lnRef idx="1">
+            <a:schemeClr val="accent1"/>
+          </a:lnRef>
+          <a:fillRef idx="3">
+            <a:schemeClr val="accent1"/>
+          </a:fillRef>
+          <a:effectRef idx="2">
+            <a:schemeClr val="accent1"/>
+          </a:effectRef>
+          <a:fontRef idx="minor">
+            <a:schemeClr val="lt1"/>
+          </a:fontRef>
+        </p:style>
+        <p:txBody>
+          <a:bodyPr rtlCol="0" anchor="t" wrap="square" lIns="182880" rIns="137160" tIns="109728"/>
+          <a:lstStyle/>
+          <a:p>
+            <a:pPr algn="ctr">
+              <a:lnSpc>
+                <a:spcPct val="100000"/>
+              </a:lnSpc>
+            </a:pPr>
+            <a:r>
+              <a:rPr sz="1250">
+                <a:solidFill>
+                  <a:srgbClr val="8BA6C0"/>
+                </a:solidFill>
+                <a:latin typeface="Courier New"/>
+              </a:rPr>
+              <a:t>-- how many selected each tooth-loss reason?</a:t>
+            </a:r>
+          </a:p>
+          <a:p>
+            <a:pPr>
+              <a:lnSpc>
+                <a:spcPct val="100000"/>
+              </a:lnSpc>
+            </a:pPr>
+            <a:r>
+              <a:rPr sz="1250">
+                <a:solidFill>
+                  <a:srgbClr val="E6EDF3"/>
+                </a:solidFill>
+                <a:latin typeface="Courier New"/>
+              </a:rPr>
+              <a:t>SELECT response_label, COUNT(*) AS n</a:t>
+            </a:r>
+          </a:p>
+          <a:p>
+            <a:pPr>
+              <a:lnSpc>
+                <a:spcPct val="100000"/>
+              </a:lnSpc>
+            </a:pPr>
+            <a:r>
+              <a:rPr sz="1250">
+                <a:solidFill>
+                  <a:srgbClr val="E6EDF3"/>
+                </a:solidFill>
+                <a:latin typeface="Courier New"/>
+              </a:rPr>
+              <a:t>FROM v_long</a:t>
+            </a:r>
+          </a:p>
+          <a:p>
+            <a:pPr>
+              <a:lnSpc>
+                <a:spcPct val="100000"/>
+              </a:lnSpc>
+            </a:pPr>
+            <a:r>
+              <a:rPr sz="1250">
+                <a:solidFill>
+                  <a:srgbClr val="E6EDF3"/>
+                </a:solidFill>
+                <a:latin typeface="Courier New"/>
+              </a:rPr>
+              <a:t>WHERE question_concept_id = 899251483</a:t>
+            </a:r>
+          </a:p>
+          <a:p>
+            <a:pPr>
+              <a:lnSpc>
+                <a:spcPct val="100000"/>
+              </a:lnSpc>
+            </a:pPr>
+            <a:r>
+              <a:rPr sz="1250">
+                <a:solidFill>
+                  <a:srgbClr val="E6EDF3"/>
+                </a:solidFill>
+                <a:latin typeface="Courier New"/>
+              </a:rPr>
+              <a:t>GROUP BY response_label</a:t>
+            </a:r>
+          </a:p>
+          <a:p>
+            <a:pPr>
+              <a:lnSpc>
+                <a:spcPct val="100000"/>
+              </a:lnSpc>
+            </a:pPr>
+            <a:r>
+              <a:rPr sz="1250">
+                <a:solidFill>
+                  <a:srgbClr val="E6EDF3"/>
+                </a:solidFill>
+                <a:latin typeface="Courier New"/>
+              </a:rPr>
+              <a:t>ORDER BY n DESC;</a:t>
+            </a:r>
+          </a:p>
+        </p:txBody>
+      </p:sp>
+      <p:graphicFrame>
+        <p:nvGraphicFramePr>
+          <p:cNvPr id="5" name="Table 4"/>
+          <p:cNvGraphicFramePr>
+            <a:graphicFrameLocks noGrp="1"/>
+          </p:cNvGraphicFramePr>
+          <p:nvPr/>
+        </p:nvGraphicFramePr>
+        <p:xfrm>
+          <a:off x="6217920" y="1371600"/>
+          <a:ext cx="5486400" cy="1828800"/>
+        </p:xfrm>
+        <a:graphic>
+          <a:graphicData uri="http://schemas.openxmlformats.org/drawingml/2006/table">
+            <a:tbl>
+              <a:tblPr firstRow="1" bandRow="1">
+                <a:tableStyleId>{5C22544A-7EE6-4342-B048-85BDC9FD1C3A}</a:tableStyleId>
+              </a:tblPr>
+              <a:tblGrid>
+                <a:gridCol w="4297680"/>
+                <a:gridCol w="1188720"/>
+              </a:tblGrid>
+              <a:tr h="365760">
+                <a:tc>
+                  <a:txBody>
+                    <a:bodyPr wrap="square"/>
+                    <a:lstStyle/>
+                    <a:p>
+                      <a:r>
+                        <a:rPr b="1" sz="1150">
+                          <a:solidFill>
+                            <a:srgbClr val="FFFFFF"/>
+                          </a:solidFill>
+                          <a:latin typeface="Calibri"/>
+                        </a:rPr>
+                        <a:t>tooth_loss_reason</a:t>
+                      </a:r>
+                    </a:p>
+                  </a:txBody>
+                  <a:tcPr marL="73152" marR="73152" marT="27432" marB="27432" anchor="ctr">
+                    <a:solidFill>
+                      <a:srgbClr val="16324F"/>
+                    </a:solidFill>
+                  </a:tcPr>
+                </a:tc>
+                <a:tc>
+                  <a:txBody>
+                    <a:bodyPr wrap="square"/>
+                    <a:lstStyle/>
+                    <a:p>
+                      <a:r>
+                        <a:rPr b="1" sz="1150">
+                          <a:solidFill>
+                            <a:srgbClr val="FFFFFF"/>
+                          </a:solidFill>
+                          <a:latin typeface="Calibri"/>
+                        </a:rPr>
+                        <a:t>n</a:t>
+                      </a:r>
+                    </a:p>
+                  </a:txBody>
+                  <a:tcPr marL="73152" marR="73152" marT="27432" marB="27432" anchor="ctr">
+                    <a:solidFill>
+                      <a:srgbClr val="16324F"/>
+                    </a:solidFill>
+                  </a:tcPr>
+                </a:tc>
+              </a:tr>
+              <a:tr h="365760">
+                <a:tc>
+                  <a:txBody>
+                    <a:bodyPr wrap="square"/>
+                    <a:lstStyle/>
+                    <a:p>
+                      <a:r>
+                        <a:rPr sz="1150" b="1">
+                          <a:solidFill>
+                            <a:srgbClr val="222A33"/>
+                          </a:solidFill>
+                          <a:latin typeface="Calibri"/>
+                        </a:rPr>
+                        <a:t>Yes, from tooth decay or disease</a:t>
+                      </a:r>
+                    </a:p>
+                  </a:txBody>
+                  <a:tcPr marL="73152" marR="73152" marT="27432" marB="27432" anchor="ctr">
+                    <a:solidFill>
+                      <a:srgbClr val="FFFFFF"/>
+                    </a:solidFill>
+                  </a:tcPr>
+                </a:tc>
+                <a:tc>
+                  <a:txBody>
+                    <a:bodyPr wrap="square"/>
+                    <a:lstStyle/>
+                    <a:p>
+                      <a:r>
+                        <a:rPr sz="1150">
+                          <a:solidFill>
+                            <a:srgbClr val="222A33"/>
+                          </a:solidFill>
+                          <a:latin typeface="Calibri"/>
+                        </a:rPr>
+                        <a:t>2</a:t>
+                      </a:r>
+                    </a:p>
+                  </a:txBody>
+                  <a:tcPr marL="73152" marR="73152" marT="27432" marB="27432" anchor="ctr">
+                    <a:solidFill>
+                      <a:srgbClr val="FFFFFF"/>
+                    </a:solidFill>
+                  </a:tcPr>
+                </a:tc>
+              </a:tr>
+              <a:tr h="365760">
+                <a:tc>
+                  <a:txBody>
+                    <a:bodyPr wrap="square"/>
+                    <a:lstStyle/>
+                    <a:p>
+                      <a:r>
+                        <a:rPr sz="1150" b="1">
+                          <a:solidFill>
+                            <a:srgbClr val="222A33"/>
+                          </a:solidFill>
+                          <a:latin typeface="Calibri"/>
+                        </a:rPr>
+                        <a:t>Yes, from accident or injury</a:t>
+                      </a:r>
+                    </a:p>
+                  </a:txBody>
+                  <a:tcPr marL="73152" marR="73152" marT="27432" marB="27432" anchor="ctr">
+                    <a:solidFill>
+                      <a:srgbClr val="EDF1F5"/>
+                    </a:solidFill>
+                  </a:tcPr>
+                </a:tc>
+                <a:tc>
+                  <a:txBody>
+                    <a:bodyPr wrap="square"/>
+                    <a:lstStyle/>
+                    <a:p>
+                      <a:r>
+                        <a:rPr sz="1150">
+                          <a:solidFill>
+                            <a:srgbClr val="222A33"/>
+                          </a:solidFill>
+                          <a:latin typeface="Calibri"/>
+                        </a:rPr>
+                        <a:t>2</a:t>
+                      </a:r>
+                    </a:p>
+                  </a:txBody>
+                  <a:tcPr marL="73152" marR="73152" marT="27432" marB="27432" anchor="ctr">
+                    <a:solidFill>
+                      <a:srgbClr val="EDF1F5"/>
+                    </a:solidFill>
+                  </a:tcPr>
+                </a:tc>
+              </a:tr>
+              <a:tr h="365760">
+                <a:tc>
+                  <a:txBody>
+                    <a:bodyPr wrap="square"/>
+                    <a:lstStyle/>
+                    <a:p>
+                      <a:r>
+                        <a:rPr sz="1150" b="1">
+                          <a:solidFill>
+                            <a:srgbClr val="222A33"/>
+                          </a:solidFill>
+                          <a:latin typeface="Calibri"/>
+                        </a:rPr>
+                        <a:t>Yes, for some other reason</a:t>
+                      </a:r>
+                    </a:p>
+                  </a:txBody>
+                  <a:tcPr marL="73152" marR="73152" marT="27432" marB="27432" anchor="ctr">
+                    <a:solidFill>
+                      <a:srgbClr val="FFFFFF"/>
+                    </a:solidFill>
+                  </a:tcPr>
+                </a:tc>
+                <a:tc>
+                  <a:txBody>
+                    <a:bodyPr wrap="square"/>
+                    <a:lstStyle/>
+                    <a:p>
+                      <a:r>
+                        <a:rPr sz="1150">
+                          <a:solidFill>
+                            <a:srgbClr val="222A33"/>
+                          </a:solidFill>
+                          <a:latin typeface="Calibri"/>
+                        </a:rPr>
+                        <a:t>1</a:t>
+                      </a:r>
+                    </a:p>
+                  </a:txBody>
+                  <a:tcPr marL="73152" marR="73152" marT="27432" marB="27432" anchor="ctr">
+                    <a:solidFill>
+                      <a:srgbClr val="FFFFFF"/>
+                    </a:solidFill>
+                  </a:tcPr>
+                </a:tc>
+              </a:tr>
+              <a:tr h="365760">
+                <a:tc>
+                  <a:txBody>
+                    <a:bodyPr wrap="square"/>
+                    <a:lstStyle/>
+                    <a:p>
+                      <a:r>
+                        <a:rPr sz="1150" b="1">
+                          <a:solidFill>
+                            <a:srgbClr val="222A33"/>
+                          </a:solidFill>
+                          <a:latin typeface="Calibri"/>
+                        </a:rPr>
+                        <a:t>No, I haven't lost any teeth</a:t>
+                      </a:r>
+                    </a:p>
+                  </a:txBody>
+                  <a:tcPr marL="73152" marR="73152" marT="27432" marB="27432" anchor="ctr">
+                    <a:solidFill>
+                      <a:srgbClr val="EDF1F5"/>
+                    </a:solidFill>
+                  </a:tcPr>
+                </a:tc>
+                <a:tc>
+                  <a:txBody>
+                    <a:bodyPr wrap="square"/>
+                    <a:lstStyle/>
+                    <a:p>
+                      <a:r>
+                        <a:rPr sz="1150">
+                          <a:solidFill>
+                            <a:srgbClr val="222A33"/>
+                          </a:solidFill>
+                          <a:latin typeface="Calibri"/>
+                        </a:rPr>
+                        <a:t>1</a:t>
+                      </a:r>
+                    </a:p>
+                  </a:txBody>
+                  <a:tcPr marL="73152" marR="73152" marT="27432" marB="27432" anchor="ctr">
+                    <a:solidFill>
+                      <a:srgbClr val="EDF1F5"/>
+                    </a:solidFill>
+                  </a:tcPr>
+                </a:tc>
+              </a:tr>
+            </a:tbl>
+          </a:graphicData>
+        </a:graphic>
+      </p:graphicFrame>
+      <p:sp>
+        <p:nvSpPr>
+          <p:cNvPr id="6" name="TextBox 5"/>
+          <p:cNvSpPr txBox="1"/>
+          <p:nvPr/>
+        </p:nvSpPr>
+        <p:spPr>
+          <a:xfrm>
+            <a:off x="457200" y="3931920"/>
+            <a:ext cx="11247120" cy="548640"/>
+          </a:xfrm>
+          <a:prstGeom prst="rect">
+            <a:avLst/>
+          </a:prstGeom>
+          <a:noFill/>
+        </p:spPr>
+        <p:txBody>
+          <a:bodyPr wrap="square">
+            <a:spAutoFit/>
+          </a:bodyPr>
+          <a:lstStyle/>
+          <a:p>
+            <a:pPr algn="l"/>
+            <a:r>
+              <a:rPr sz="1300" b="0" i="1">
+                <a:solidFill>
+                  <a:srgbClr val="5A636E"/>
+                </a:solidFill>
+                <a:latin typeface="Calibri"/>
+              </a:rPr>
+              <a:t>In wide, that means summing N ever-changing 0/1 indicator columns; in long it's the same group-by you'd write for any question.</a:t>
+            </a:r>
+          </a:p>
+        </p:txBody>
+      </p:sp>
+      <p:sp>
+        <p:nvSpPr>
+          <p:cNvPr id="7" name="TextBox 6"/>
+          <p:cNvSpPr txBox="1"/>
+          <p:nvPr/>
+        </p:nvSpPr>
+        <p:spPr>
+          <a:xfrm>
+            <a:off x="457200" y="5897880"/>
+            <a:ext cx="11247120" cy="457200"/>
+          </a:xfrm>
+          <a:prstGeom prst="rect">
+            <a:avLst/>
+          </a:prstGeom>
+          <a:noFill/>
+        </p:spPr>
+        <p:txBody>
+          <a:bodyPr wrap="square">
+            <a:spAutoFit/>
+          </a:bodyPr>
+          <a:lstStyle/>
+          <a:p>
+            <a:pPr algn="l"/>
+            <a:r>
+              <a:rPr sz="1400" b="1" i="0">
+                <a:solidFill>
+                  <a:srgbClr val="CC7D15"/>
+                </a:solidFill>
+                <a:latin typeface="Calibri"/>
+              </a:rPr>
+              <a:t>Swap the concept id and the same one-liner counts smoking, education, anything — one pattern for every question.</a:t>
+            </a:r>
+          </a:p>
+        </p:txBody>
+      </p:sp>
+    </p:spTree>
+  </p:cSld>
+  <p:clrMapOvr>
+    <a:masterClrMapping/>
+  </p:clrMapOvr>
+</p:sld>
+</file>
+
+<file path=ppt/slides/slide2.xml><?xml version="1.0" encoding="utf-8"?>
+<p:sld xmlns:a="http://schemas.openxmlformats.org/drawingml/2006/main" xmlns:p="http://schemas.openxmlformats.org/presentationml/2006/main" xmlns:r="http://schemas.openxmlformats.org/officeDocument/2006/relationships">
+  <p:cSld>
+    <p:spTree>
+      <p:nvGrpSpPr>
+        <p:cNvPr id="1" name=""/>
+        <p:cNvGrpSpPr/>
+        <p:nvPr/>
+      </p:nvGrpSpPr>
+      <p:grpSpPr/>
+      <p:sp>
+        <p:nvSpPr>
+          <p:cNvPr id="2" name="Rectangle 1"/>
+          <p:cNvSpPr/>
+          <p:nvPr/>
+        </p:nvSpPr>
+        <p:spPr>
+          <a:xfrm>
+            <a:off x="0" y="0"/>
+            <a:ext cx="12191695" cy="1051560"/>
+          </a:xfrm>
+          <a:prstGeom prst="rect">
+            <a:avLst/>
+          </a:prstGeom>
+          <a:solidFill>
+            <a:srgbClr val="16324F"/>
+          </a:solidFill>
+          <a:ln>
+            <a:noFill/>
+          </a:ln>
+          <a:effectLst/>
+        </p:spPr>
+        <p:style>
+          <a:lnRef idx="1">
+            <a:schemeClr val="accent1"/>
+          </a:lnRef>
+          <a:fillRef idx="3">
+            <a:schemeClr val="accent1"/>
+          </a:fillRef>
+          <a:effectRef idx="2">
+            <a:schemeClr val="accent1"/>
+          </a:effectRef>
+          <a:fontRef idx="minor">
+            <a:schemeClr val="lt1"/>
+          </a:fontRef>
+        </p:style>
+        <p:txBody>
+          <a:bodyPr rtlCol="0" anchor="ctr" lIns="457200" tIns="109728"/>
+          <a:lstStyle/>
+          <a:p>
+            <a:pPr algn="ctr"/>
+            <a:r>
+              <a:rPr sz="2800" b="1">
+                <a:solidFill>
+                  <a:srgbClr val="FFFFFF"/>
+                </a:solidFill>
+                <a:latin typeface="Calibri"/>
+              </a:rPr>
+              <a:t>Why a data model?</a:t>
+            </a:r>
+          </a:p>
+          <a:p>
+            <a:r>
+              <a:rPr sz="1300" i="1">
+                <a:solidFill>
+                  <a:srgbClr val="BBD5D7"/>
+                </a:solidFill>
+              </a:rPr>
+              <a:t>Make the data explain itself — so analysis doesn't depend on tribal knowledge or bespoke code</a:t>
+            </a:r>
+          </a:p>
+        </p:txBody>
+      </p:sp>
+      <p:sp>
+        <p:nvSpPr>
+          <p:cNvPr id="3" name="Rectangle 2"/>
+          <p:cNvSpPr/>
+          <p:nvPr/>
+        </p:nvSpPr>
+        <p:spPr>
+          <a:xfrm>
+            <a:off x="0" y="1051560"/>
+            <a:ext cx="12191695" cy="54864"/>
+          </a:xfrm>
+          <a:prstGeom prst="rect">
+            <a:avLst/>
+          </a:prstGeom>
+          <a:solidFill>
+            <a:srgbClr val="2E8B8B"/>
+          </a:solidFill>
+          <a:ln>
+            <a:noFill/>
+          </a:ln>
+          <a:effectLst/>
+        </p:spPr>
+        <p:style>
+          <a:lnRef idx="1">
+            <a:schemeClr val="accent1"/>
+          </a:lnRef>
+          <a:fillRef idx="3">
+            <a:schemeClr val="accent1"/>
+          </a:fillRef>
+          <a:effectRef idx="2">
+            <a:schemeClr val="accent1"/>
+          </a:effectRef>
+          <a:fontRef idx="minor">
+            <a:schemeClr val="lt1"/>
+          </a:fontRef>
+        </p:style>
+        <p:txBody>
+          <a:bodyPr rtlCol="0" anchor="ctr"/>
+          <a:lstStyle/>
+          <a:p>
+            <a:pPr algn="ctr"/>
+          </a:p>
+        </p:txBody>
+      </p:sp>
+      <p:sp>
+        <p:nvSpPr>
+          <p:cNvPr id="4" name="Rounded Rectangle 3"/>
+          <p:cNvSpPr/>
+          <p:nvPr/>
+        </p:nvSpPr>
+        <p:spPr>
+          <a:xfrm>
+            <a:off x="457200" y="1874519"/>
+            <a:ext cx="3575304" cy="1737360"/>
+          </a:xfrm>
+          <a:prstGeom prst="roundRect">
+            <a:avLst/>
+          </a:prstGeom>
+          <a:solidFill>
+            <a:srgbClr val="EDF1F5"/>
+          </a:solidFill>
+          <a:ln>
+            <a:solidFill>
+              <a:srgbClr val="2E8B8B"/>
+            </a:solidFill>
+          </a:ln>
+          <a:effectLst/>
+        </p:spPr>
+        <p:style>
+          <a:lnRef idx="1">
+            <a:schemeClr val="accent1"/>
+          </a:lnRef>
+          <a:fillRef idx="3">
+            <a:schemeClr val="accent1"/>
+          </a:fillRef>
+          <a:effectRef idx="2">
+            <a:schemeClr val="accent1"/>
+          </a:effectRef>
+          <a:fontRef idx="minor">
+            <a:schemeClr val="lt1"/>
+          </a:fontRef>
+        </p:style>
+        <p:txBody>
+          <a:bodyPr rtlCol="0" anchor="t" wrap="square" lIns="164592" rIns="164592" tIns="128016"/>
+          <a:lstStyle/>
+          <a:p>
+            <a:pPr algn="ctr"/>
+            <a:r>
+              <a:rPr b="1" sz="1600">
+                <a:solidFill>
+                  <a:srgbClr val="16324F"/>
+                </a:solidFill>
+                <a:latin typeface="Calibri"/>
+              </a:rPr>
+              <a:t>Self-describing</a:t>
+            </a:r>
+          </a:p>
+          <a:p>
+            <a:pPr>
+              <a:spcBef>
+                <a:spcPts val="500"/>
+              </a:spcBef>
+            </a:pPr>
+            <a:r>
+              <a:rPr sz="1150">
+                <a:solidFill>
+                  <a:srgbClr val="5A636E"/>
+                </a:solidFill>
+                <a:latin typeface="Calibri"/>
+              </a:rPr>
+              <a:t>Meaning travels with the data — no decoder ring required.</a:t>
+            </a:r>
+          </a:p>
+        </p:txBody>
+      </p:sp>
+      <p:sp>
+        <p:nvSpPr>
+          <p:cNvPr id="5" name="Rounded Rectangle 4"/>
+          <p:cNvSpPr/>
+          <p:nvPr/>
+        </p:nvSpPr>
+        <p:spPr>
+          <a:xfrm>
+            <a:off x="4306824" y="1874519"/>
+            <a:ext cx="3575304" cy="1737360"/>
+          </a:xfrm>
+          <a:prstGeom prst="roundRect">
+            <a:avLst/>
+          </a:prstGeom>
+          <a:solidFill>
+            <a:srgbClr val="EDF1F5"/>
+          </a:solidFill>
+          <a:ln>
+            <a:solidFill>
+              <a:srgbClr val="2E8B8B"/>
+            </a:solidFill>
+          </a:ln>
+          <a:effectLst/>
+        </p:spPr>
+        <p:style>
+          <a:lnRef idx="1">
+            <a:schemeClr val="accent1"/>
+          </a:lnRef>
+          <a:fillRef idx="3">
+            <a:schemeClr val="accent1"/>
+          </a:fillRef>
+          <a:effectRef idx="2">
+            <a:schemeClr val="accent1"/>
+          </a:effectRef>
+          <a:fontRef idx="minor">
+            <a:schemeClr val="lt1"/>
+          </a:fontRef>
+        </p:style>
+        <p:txBody>
+          <a:bodyPr rtlCol="0" anchor="t" wrap="square" lIns="164592" rIns="164592" tIns="128016"/>
+          <a:lstStyle/>
+          <a:p>
+            <a:pPr algn="ctr"/>
+            <a:r>
+              <a:rPr b="1" sz="1600">
+                <a:solidFill>
+                  <a:srgbClr val="16324F"/>
+                </a:solidFill>
+                <a:latin typeface="Calibri"/>
+              </a:rPr>
+              <a:t>No tribal knowledge</a:t>
+            </a:r>
+          </a:p>
+          <a:p>
+            <a:pPr>
+              <a:spcBef>
+                <a:spcPts val="500"/>
+              </a:spcBef>
+            </a:pPr>
+            <a:r>
+              <a:rPr sz="1150">
+                <a:solidFill>
+                  <a:srgbClr val="5A636E"/>
+                </a:solidFill>
+                <a:latin typeface="Calibri"/>
+              </a:rPr>
+              <a:t>Labels, structure &amp; valid values live in the data — query it correctly without insider context.</a:t>
+            </a:r>
+          </a:p>
+        </p:txBody>
+      </p:sp>
+      <p:sp>
+        <p:nvSpPr>
+          <p:cNvPr id="6" name="Rounded Rectangle 5"/>
+          <p:cNvSpPr/>
+          <p:nvPr/>
+        </p:nvSpPr>
+        <p:spPr>
+          <a:xfrm>
+            <a:off x="8156448" y="1874519"/>
+            <a:ext cx="3575304" cy="1737360"/>
+          </a:xfrm>
+          <a:prstGeom prst="roundRect">
+            <a:avLst/>
+          </a:prstGeom>
+          <a:solidFill>
+            <a:srgbClr val="EDF1F5"/>
+          </a:solidFill>
+          <a:ln>
+            <a:solidFill>
+              <a:srgbClr val="2E8B8B"/>
+            </a:solidFill>
+          </a:ln>
+          <a:effectLst/>
+        </p:spPr>
+        <p:style>
+          <a:lnRef idx="1">
+            <a:schemeClr val="accent1"/>
+          </a:lnRef>
+          <a:fillRef idx="3">
+            <a:schemeClr val="accent1"/>
+          </a:fillRef>
+          <a:effectRef idx="2">
+            <a:schemeClr val="accent1"/>
+          </a:effectRef>
+          <a:fontRef idx="minor">
+            <a:schemeClr val="lt1"/>
+          </a:fontRef>
+        </p:style>
+        <p:txBody>
+          <a:bodyPr rtlCol="0" anchor="t" wrap="square" lIns="164592" rIns="164592" tIns="128016"/>
+          <a:lstStyle/>
+          <a:p>
+            <a:pPr algn="ctr"/>
+            <a:r>
+              <a:rPr b="1" sz="1600">
+                <a:solidFill>
+                  <a:srgbClr val="16324F"/>
+                </a:solidFill>
+                <a:latin typeface="Calibri"/>
+              </a:rPr>
+              <a:t>Metadata in the data</a:t>
+            </a:r>
+          </a:p>
+          <a:p>
+            <a:pPr>
+              <a:spcBef>
+                <a:spcPts val="500"/>
+              </a:spcBef>
+            </a:pPr>
+            <a:r>
+              <a:rPr sz="1150">
+                <a:solidFill>
+                  <a:srgbClr val="5A636E"/>
+                </a:solidFill>
+                <a:latin typeface="Calibri"/>
+              </a:rPr>
+              <a:t>Not in side-car spreadsheets or scripts that drift out of sync.</a:t>
+            </a:r>
+          </a:p>
+        </p:txBody>
+      </p:sp>
+      <p:sp>
+        <p:nvSpPr>
+          <p:cNvPr id="7" name="Rounded Rectangle 6"/>
+          <p:cNvSpPr/>
+          <p:nvPr/>
+        </p:nvSpPr>
+        <p:spPr>
+          <a:xfrm>
+            <a:off x="457200" y="3794760"/>
+            <a:ext cx="3575304" cy="1737360"/>
+          </a:xfrm>
+          <a:prstGeom prst="roundRect">
+            <a:avLst/>
+          </a:prstGeom>
+          <a:solidFill>
+            <a:srgbClr val="EDF1F5"/>
+          </a:solidFill>
+          <a:ln>
+            <a:solidFill>
+              <a:srgbClr val="2E8B8B"/>
+            </a:solidFill>
+          </a:ln>
+          <a:effectLst/>
+        </p:spPr>
+        <p:style>
+          <a:lnRef idx="1">
+            <a:schemeClr val="accent1"/>
+          </a:lnRef>
+          <a:fillRef idx="3">
+            <a:schemeClr val="accent1"/>
+          </a:fillRef>
+          <a:effectRef idx="2">
+            <a:schemeClr val="accent1"/>
+          </a:effectRef>
+          <a:fontRef idx="minor">
+            <a:schemeClr val="lt1"/>
+          </a:fontRef>
+        </p:style>
+        <p:txBody>
+          <a:bodyPr rtlCol="0" anchor="t" wrap="square" lIns="164592" rIns="164592" tIns="128016"/>
+          <a:lstStyle/>
+          <a:p>
+            <a:pPr algn="ctr"/>
+            <a:r>
+              <a:rPr b="1" sz="1600">
+                <a:solidFill>
+                  <a:srgbClr val="16324F"/>
+                </a:solidFill>
+                <a:latin typeface="Calibri"/>
+              </a:rPr>
+              <a:t>Standardized analyses</a:t>
+            </a:r>
+          </a:p>
+          <a:p>
+            <a:pPr>
+              <a:spcBef>
+                <a:spcPts val="500"/>
+              </a:spcBef>
+            </a:pPr>
+            <a:r>
+              <a:rPr sz="1150">
+                <a:solidFill>
+                  <a:srgbClr val="5A636E"/>
+                </a:solidFill>
+                <a:latin typeface="Calibri"/>
+              </a:rPr>
+              <a:t>The same question is answered the same way by everyone.</a:t>
+            </a:r>
+          </a:p>
+        </p:txBody>
+      </p:sp>
+      <p:sp>
+        <p:nvSpPr>
+          <p:cNvPr id="8" name="Rounded Rectangle 7"/>
+          <p:cNvSpPr/>
+          <p:nvPr/>
+        </p:nvSpPr>
+        <p:spPr>
+          <a:xfrm>
+            <a:off x="4306824" y="3794760"/>
+            <a:ext cx="3575304" cy="1737360"/>
+          </a:xfrm>
+          <a:prstGeom prst="roundRect">
+            <a:avLst/>
+          </a:prstGeom>
+          <a:solidFill>
+            <a:srgbClr val="EDF1F5"/>
+          </a:solidFill>
+          <a:ln>
+            <a:solidFill>
+              <a:srgbClr val="2E8B8B"/>
+            </a:solidFill>
+          </a:ln>
+          <a:effectLst/>
+        </p:spPr>
+        <p:style>
+          <a:lnRef idx="1">
+            <a:schemeClr val="accent1"/>
+          </a:lnRef>
+          <a:fillRef idx="3">
+            <a:schemeClr val="accent1"/>
+          </a:fillRef>
+          <a:effectRef idx="2">
+            <a:schemeClr val="accent1"/>
+          </a:effectRef>
+          <a:fontRef idx="minor">
+            <a:schemeClr val="lt1"/>
+          </a:fontRef>
+        </p:style>
+        <p:txBody>
+          <a:bodyPr rtlCol="0" anchor="t" wrap="square" lIns="164592" rIns="164592" tIns="128016"/>
+          <a:lstStyle/>
+          <a:p>
+            <a:pPr algn="ctr"/>
+            <a:r>
+              <a:rPr b="1" sz="1600">
+                <a:solidFill>
+                  <a:srgbClr val="16324F"/>
+                </a:solidFill>
+                <a:latin typeface="Calibri"/>
+              </a:rPr>
+              <a:t>A schema contract</a:t>
+            </a:r>
+          </a:p>
+          <a:p>
+            <a:pPr>
+              <a:spcBef>
+                <a:spcPts val="500"/>
+              </a:spcBef>
+            </a:pPr>
+            <a:r>
+              <a:rPr sz="1150">
+                <a:solidFill>
+                  <a:srgbClr val="5A636E"/>
+                </a:solidFill>
+                <a:latin typeface="Calibri"/>
+              </a:rPr>
+              <a:t>Tools built on it keep running when new data arrives.</a:t>
+            </a:r>
+          </a:p>
+        </p:txBody>
+      </p:sp>
+      <p:sp>
+        <p:nvSpPr>
+          <p:cNvPr id="9" name="Rounded Rectangle 8"/>
+          <p:cNvSpPr/>
+          <p:nvPr/>
+        </p:nvSpPr>
+        <p:spPr>
+          <a:xfrm>
+            <a:off x="8156448" y="3794760"/>
+            <a:ext cx="3575304" cy="1737360"/>
+          </a:xfrm>
+          <a:prstGeom prst="roundRect">
+            <a:avLst/>
+          </a:prstGeom>
+          <a:solidFill>
+            <a:srgbClr val="EDF1F5"/>
+          </a:solidFill>
+          <a:ln>
+            <a:solidFill>
+              <a:srgbClr val="2E8B8B"/>
+            </a:solidFill>
+          </a:ln>
+          <a:effectLst/>
+        </p:spPr>
+        <p:style>
+          <a:lnRef idx="1">
+            <a:schemeClr val="accent1"/>
+          </a:lnRef>
+          <a:fillRef idx="3">
+            <a:schemeClr val="accent1"/>
+          </a:fillRef>
+          <a:effectRef idx="2">
+            <a:schemeClr val="accent1"/>
+          </a:effectRef>
+          <a:fontRef idx="minor">
+            <a:schemeClr val="lt1"/>
+          </a:fontRef>
+        </p:style>
+        <p:txBody>
+          <a:bodyPr rtlCol="0" anchor="t" wrap="square" lIns="164592" rIns="164592" tIns="128016"/>
+          <a:lstStyle/>
+          <a:p>
+            <a:pPr algn="ctr"/>
+            <a:r>
+              <a:rPr b="1" sz="1600">
+                <a:solidFill>
+                  <a:srgbClr val="16324F"/>
+                </a:solidFill>
+                <a:latin typeface="Calibri"/>
+              </a:rPr>
+              <a:t>Shared abstractions</a:t>
+            </a:r>
+          </a:p>
+          <a:p>
+            <a:pPr>
+              <a:spcBef>
+                <a:spcPts val="500"/>
+              </a:spcBef>
+            </a:pPr>
+            <a:r>
+              <a:rPr sz="1150">
+                <a:solidFill>
+                  <a:srgbClr val="5A636E"/>
+                </a:solidFill>
+                <a:latin typeface="Calibri"/>
+              </a:rPr>
+              <a:t>Every select-all handled one way; every loop one way — no per-question code.</a:t>
+            </a:r>
+          </a:p>
+        </p:txBody>
+      </p:sp>
+      <p:sp>
+        <p:nvSpPr>
+          <p:cNvPr id="10" name="Rounded Rectangle 9"/>
+          <p:cNvSpPr/>
+          <p:nvPr/>
+        </p:nvSpPr>
+        <p:spPr>
+          <a:xfrm>
+            <a:off x="457200" y="5806440"/>
+            <a:ext cx="11274552" cy="658368"/>
+          </a:xfrm>
+          <a:prstGeom prst="roundRect">
+            <a:avLst/>
+          </a:prstGeom>
+          <a:solidFill>
+            <a:srgbClr val="16324F"/>
+          </a:solidFill>
+          <a:ln>
+            <a:noFill/>
+          </a:ln>
+          <a:effectLst/>
+        </p:spPr>
+        <p:style>
+          <a:lnRef idx="1">
+            <a:schemeClr val="accent1"/>
+          </a:lnRef>
+          <a:fillRef idx="3">
+            <a:schemeClr val="accent1"/>
+          </a:fillRef>
+          <a:effectRef idx="2">
+            <a:schemeClr val="accent1"/>
+          </a:effectRef>
+          <a:fontRef idx="minor">
+            <a:schemeClr val="lt1"/>
+          </a:fontRef>
+        </p:style>
+        <p:txBody>
+          <a:bodyPr rtlCol="0" anchor="ctr" wrap="square" lIns="228600"/>
+          <a:lstStyle/>
+          <a:p>
+            <a:pPr algn="ctr"/>
+            <a:r>
+              <a:rPr sz="1400" b="1">
+                <a:solidFill>
+                  <a:srgbClr val="FFFFFF"/>
+                </a:solidFill>
+                <a:latin typeface="Calibri"/>
+              </a:rPr>
+              <a:t>Today that knowledge lives in column-name conventions, spreadsheets, and analysts' heads. A data model puts it in the data.</a:t>
+            </a:r>
+          </a:p>
+        </p:txBody>
+      </p:sp>
+    </p:spTree>
+  </p:cSld>
+  <p:clrMapOvr>
+    <a:masterClrMapping/>
+  </p:clrMapOvr>
+</p:sld>
+</file>
+
+<file path=ppt/slides/slide20.xml><?xml version="1.0" encoding="utf-8"?>
 <p:sld xmlns:a="http://schemas.openxmlformats.org/drawingml/2006/main" xmlns:p="http://schemas.openxmlformats.org/presentationml/2006/main" xmlns:r="http://schemas.openxmlformats.org/officeDocument/2006/relationships">
   <p:cSld>
     <p:spTree>
@@ -7569,7 +11646,7 @@
 </p:sld>
 </file>
 
-<file path=ppt/slides/slide2.xml><?xml version="1.0" encoding="utf-8"?>
+<file path=ppt/slides/slide3.xml><?xml version="1.0" encoding="utf-8"?>
 <p:sld xmlns:a="http://schemas.openxmlformats.org/drawingml/2006/main" xmlns:p="http://schemas.openxmlformats.org/presentationml/2006/main" xmlns:r="http://schemas.openxmlformats.org/officeDocument/2006/relationships">
   <p:cSld>
     <p:spTree>
@@ -7627,7 +11704,7 @@
                 </a:solidFill>
                 <a:latin typeface="Calibri"/>
               </a:rPr>
-              <a:t>Why a data model at all?</a:t>
+              <a:t>…and it's the OMOP lesson — applied to our own data</a:t>
             </a:r>
           </a:p>
           <a:p>
@@ -8020,7 +12097,7 @@
 </p:sld>
 </file>
 
-<file path=ppt/slides/slide3.xml><?xml version="1.0" encoding="utf-8"?>
+<file path=ppt/slides/slide4.xml><?xml version="1.0" encoding="utf-8"?>
 <p:sld xmlns:a="http://schemas.openxmlformats.org/drawingml/2006/main" xmlns:p="http://schemas.openxmlformats.org/presentationml/2006/main" xmlns:r="http://schemas.openxmlformats.org/officeDocument/2006/relationships">
   <p:cSld>
     <p:spTree>
@@ -8283,7 +12360,7 @@
 </p:sld>
 </file>
 
-<file path=ppt/slides/slide4.xml><?xml version="1.0" encoding="utf-8"?>
+<file path=ppt/slides/slide5.xml><?xml version="1.0" encoding="utf-8"?>
 <p:sld xmlns:a="http://schemas.openxmlformats.org/drawingml/2006/main" xmlns:p="http://schemas.openxmlformats.org/presentationml/2006/main" xmlns:r="http://schemas.openxmlformats.org/officeDocument/2006/relationships">
   <p:cSld>
     <p:spTree>
@@ -8565,7 +12642,7 @@
 </p:sld>
 </file>
 
-<file path=ppt/slides/slide5.xml><?xml version="1.0" encoding="utf-8"?>
+<file path=ppt/slides/slide6.xml><?xml version="1.0" encoding="utf-8"?>
 <p:sld xmlns:a="http://schemas.openxmlformats.org/drawingml/2006/main" xmlns:p="http://schemas.openxmlformats.org/presentationml/2006/main" xmlns:r="http://schemas.openxmlformats.org/officeDocument/2006/relationships">
   <p:cSld>
     <p:spTree>
@@ -9263,7 +13340,7 @@
 </p:sld>
 </file>
 
-<file path=ppt/slides/slide6.xml><?xml version="1.0" encoding="utf-8"?>
+<file path=ppt/slides/slide7.xml><?xml version="1.0" encoding="utf-8"?>
 <p:sld xmlns:a="http://schemas.openxmlformats.org/drawingml/2006/main" xmlns:p="http://schemas.openxmlformats.org/presentationml/2006/main" xmlns:r="http://schemas.openxmlformats.org/officeDocument/2006/relationships">
   <p:cSld>
     <p:spTree>
@@ -9510,7 +13587,7 @@
 </p:sld>
 </file>
 
-<file path=ppt/slides/slide7.xml><?xml version="1.0" encoding="utf-8"?>
+<file path=ppt/slides/slide8.xml><?xml version="1.0" encoding="utf-8"?>
 <p:sld xmlns:a="http://schemas.openxmlformats.org/drawingml/2006/main" xmlns:p="http://schemas.openxmlformats.org/presentationml/2006/main" xmlns:r="http://schemas.openxmlformats.org/officeDocument/2006/relationships">
   <p:cSld>
     <p:spTree>
@@ -9694,7 +13771,7 @@
 </p:sld>
 </file>
 
-<file path=ppt/slides/slide8.xml><?xml version="1.0" encoding="utf-8"?>
+<file path=ppt/slides/slide9.xml><?xml version="1.0" encoding="utf-8"?>
 <p:sld xmlns:a="http://schemas.openxmlformats.org/drawingml/2006/main" xmlns:p="http://schemas.openxmlformats.org/presentationml/2006/main" xmlns:r="http://schemas.openxmlformats.org/officeDocument/2006/relationships">
   <p:cSld>
     <p:spTree>
@@ -10244,533 +14321,6 @@
                 <a:latin typeface="Calibri"/>
               </a:rPr>
               <a:t>Phased &amp; low-risk: the dictionary tables are untouched; this is a view we layer on — adopt it where it helps, keep everything else as-is.</a:t>
-            </a:r>
-          </a:p>
-        </p:txBody>
-      </p:sp>
-    </p:spTree>
-  </p:cSld>
-  <p:clrMapOvr>
-    <a:masterClrMapping/>
-  </p:clrMapOvr>
-</p:sld>
-</file>
-
-<file path=ppt/slides/slide9.xml><?xml version="1.0" encoding="utf-8"?>
-<p:sld xmlns:a="http://schemas.openxmlformats.org/drawingml/2006/main" xmlns:p="http://schemas.openxmlformats.org/presentationml/2006/main" xmlns:r="http://schemas.openxmlformats.org/officeDocument/2006/relationships">
-  <p:cSld>
-    <p:spTree>
-      <p:nvGrpSpPr>
-        <p:cNvPr id="1" name=""/>
-        <p:cNvGrpSpPr/>
-        <p:nvPr/>
-      </p:nvGrpSpPr>
-      <p:grpSpPr/>
-      <p:sp>
-        <p:nvSpPr>
-          <p:cNvPr id="2" name="Rectangle 1"/>
-          <p:cNvSpPr/>
-          <p:nvPr/>
-        </p:nvSpPr>
-        <p:spPr>
-          <a:xfrm>
-            <a:off x="0" y="0"/>
-            <a:ext cx="12191695" cy="1051560"/>
-          </a:xfrm>
-          <a:prstGeom prst="rect">
-            <a:avLst/>
-          </a:prstGeom>
-          <a:solidFill>
-            <a:srgbClr val="16324F"/>
-          </a:solidFill>
-          <a:ln>
-            <a:noFill/>
-          </a:ln>
-          <a:effectLst/>
-        </p:spPr>
-        <p:style>
-          <a:lnRef idx="1">
-            <a:schemeClr val="accent1"/>
-          </a:lnRef>
-          <a:fillRef idx="3">
-            <a:schemeClr val="accent1"/>
-          </a:fillRef>
-          <a:effectRef idx="2">
-            <a:schemeClr val="accent1"/>
-          </a:effectRef>
-          <a:fontRef idx="minor">
-            <a:schemeClr val="lt1"/>
-          </a:fontRef>
-        </p:style>
-        <p:txBody>
-          <a:bodyPr rtlCol="0" anchor="ctr" lIns="457200" tIns="109728"/>
-          <a:lstStyle/>
-          <a:p>
-            <a:pPr algn="ctr"/>
-            <a:r>
-              <a:rPr sz="2800" b="1">
-                <a:solidFill>
-                  <a:srgbClr val="FFFFFF"/>
-                </a:solidFill>
-                <a:latin typeface="Calibri"/>
-              </a:rPr>
-              <a:t>A two-phase path</a:t>
-            </a:r>
-          </a:p>
-          <a:p>
-            <a:r>
-              <a:rPr sz="1300" i="1">
-                <a:solidFill>
-                  <a:srgbClr val="BBD5D7"/>
-                </a:solidFill>
-              </a:rPr>
-              <a:t>Phase 1 proves it cheaply · Phase 2 builds the governed warehouse</a:t>
-            </a:r>
-          </a:p>
-        </p:txBody>
-      </p:sp>
-      <p:sp>
-        <p:nvSpPr>
-          <p:cNvPr id="3" name="Rectangle 2"/>
-          <p:cNvSpPr/>
-          <p:nvPr/>
-        </p:nvSpPr>
-        <p:spPr>
-          <a:xfrm>
-            <a:off x="0" y="1051560"/>
-            <a:ext cx="12191695" cy="54864"/>
-          </a:xfrm>
-          <a:prstGeom prst="rect">
-            <a:avLst/>
-          </a:prstGeom>
-          <a:solidFill>
-            <a:srgbClr val="2E8B8B"/>
-          </a:solidFill>
-          <a:ln>
-            <a:noFill/>
-          </a:ln>
-          <a:effectLst/>
-        </p:spPr>
-        <p:style>
-          <a:lnRef idx="1">
-            <a:schemeClr val="accent1"/>
-          </a:lnRef>
-          <a:fillRef idx="3">
-            <a:schemeClr val="accent1"/>
-          </a:fillRef>
-          <a:effectRef idx="2">
-            <a:schemeClr val="accent1"/>
-          </a:effectRef>
-          <a:fontRef idx="minor">
-            <a:schemeClr val="lt1"/>
-          </a:fontRef>
-        </p:style>
-        <p:txBody>
-          <a:bodyPr rtlCol="0" anchor="ctr"/>
-          <a:lstStyle/>
-          <a:p>
-            <a:pPr algn="ctr"/>
-          </a:p>
-        </p:txBody>
-      </p:sp>
-      <p:graphicFrame>
-        <p:nvGraphicFramePr>
-          <p:cNvPr id="4" name="Table 3"/>
-          <p:cNvGraphicFramePr>
-            <a:graphicFrameLocks noGrp="1"/>
-          </p:cNvGraphicFramePr>
-          <p:nvPr/>
-        </p:nvGraphicFramePr>
-        <p:xfrm>
-          <a:off x="548640" y="1554480"/>
-          <a:ext cx="11064240" cy="3108960"/>
-        </p:xfrm>
-        <a:graphic>
-          <a:graphicData uri="http://schemas.openxmlformats.org/drawingml/2006/table">
-            <a:tbl>
-              <a:tblPr firstRow="1" bandRow="1">
-                <a:tableStyleId>{5C22544A-7EE6-4342-B048-85BDC9FD1C3A}</a:tableStyleId>
-              </a:tblPr>
-              <a:tblGrid>
-                <a:gridCol w="1554480"/>
-                <a:gridCol w="4754880"/>
-                <a:gridCol w="4754880"/>
-              </a:tblGrid>
-              <a:tr h="621792">
-                <a:tc>
-                  <a:txBody>
-                    <a:bodyPr wrap="square"/>
-                    <a:lstStyle/>
-                    <a:p>
-                      <a:r>
-                        <a:rPr b="1" sz="1400">
-                          <a:solidFill>
-                            <a:srgbClr val="FFFFFF"/>
-                          </a:solidFill>
-                          <a:latin typeface="Calibri"/>
-                        </a:rPr>
-                        <a:t/>
-                      </a:r>
-                    </a:p>
-                  </a:txBody>
-                  <a:tcPr marL="73152" marR="73152" marT="27432" marB="27432" anchor="ctr">
-                    <a:solidFill>
-                      <a:srgbClr val="16324F"/>
-                    </a:solidFill>
-                  </a:tcPr>
-                </a:tc>
-                <a:tc>
-                  <a:txBody>
-                    <a:bodyPr wrap="square"/>
-                    <a:lstStyle/>
-                    <a:p>
-                      <a:r>
-                        <a:rPr b="1" sz="1400">
-                          <a:solidFill>
-                            <a:srgbClr val="FFFFFF"/>
-                          </a:solidFill>
-                          <a:latin typeface="Calibri"/>
-                        </a:rPr>
-                        <a:t>Phase 1 — Dictionary-Direct</a:t>
-                      </a:r>
-                    </a:p>
-                  </a:txBody>
-                  <a:tcPr marL="73152" marR="73152" marT="27432" marB="27432" anchor="ctr">
-                    <a:solidFill>
-                      <a:srgbClr val="16324F"/>
-                    </a:solidFill>
-                  </a:tcPr>
-                </a:tc>
-                <a:tc>
-                  <a:txBody>
-                    <a:bodyPr wrap="square"/>
-                    <a:lstStyle/>
-                    <a:p>
-                      <a:r>
-                        <a:rPr b="1" sz="1400">
-                          <a:solidFill>
-                            <a:srgbClr val="FFFFFF"/>
-                          </a:solidFill>
-                          <a:latin typeface="Calibri"/>
-                        </a:rPr>
-                        <a:t>Phase 2 — PR2 warehouse</a:t>
-                      </a:r>
-                    </a:p>
-                  </a:txBody>
-                  <a:tcPr marL="73152" marR="73152" marT="27432" marB="27432" anchor="ctr">
-                    <a:solidFill>
-                      <a:srgbClr val="16324F"/>
-                    </a:solidFill>
-                  </a:tcPr>
-                </a:tc>
-              </a:tr>
-              <a:tr h="621792">
-                <a:tc>
-                  <a:txBody>
-                    <a:bodyPr wrap="square"/>
-                    <a:lstStyle/>
-                    <a:p>
-                      <a:r>
-                        <a:rPr sz="1400" b="1">
-                          <a:solidFill>
-                            <a:srgbClr val="222A33"/>
-                          </a:solidFill>
-                          <a:latin typeface="Calibri"/>
-                        </a:rPr>
-                        <a:t>What</a:t>
-                      </a:r>
-                    </a:p>
-                  </a:txBody>
-                  <a:tcPr marL="73152" marR="73152" marT="27432" marB="27432" anchor="ctr">
-                    <a:solidFill>
-                      <a:srgbClr val="FFFFFF"/>
-                    </a:solidFill>
-                  </a:tcPr>
-                </a:tc>
-                <a:tc>
-                  <a:txBody>
-                    <a:bodyPr wrap="square"/>
-                    <a:lstStyle/>
-                    <a:p>
-                      <a:r>
-                        <a:rPr sz="1400">
-                          <a:solidFill>
-                            <a:srgbClr val="222A33"/>
-                          </a:solidFill>
-                          <a:latin typeface="Calibri"/>
-                        </a:rPr>
-                        <a:t>dictionary as-is + 1 responses table</a:t>
-                      </a:r>
-                    </a:p>
-                  </a:txBody>
-                  <a:tcPr marL="73152" marR="73152" marT="27432" marB="27432" anchor="ctr">
-                    <a:solidFill>
-                      <a:srgbClr val="FFFFFF"/>
-                    </a:solidFill>
-                  </a:tcPr>
-                </a:tc>
-                <a:tc>
-                  <a:txBody>
-                    <a:bodyPr wrap="square"/>
-                    <a:lstStyle/>
-                    <a:p>
-                      <a:r>
-                        <a:rPr sz="1400">
-                          <a:solidFill>
-                            <a:srgbClr val="222A33"/>
-                          </a:solidFill>
-                          <a:latin typeface="Calibri"/>
-                        </a:rPr>
-                        <a:t>cleaned dims, placement bridge, sessions, governance</a:t>
-                      </a:r>
-                    </a:p>
-                  </a:txBody>
-                  <a:tcPr marL="73152" marR="73152" marT="27432" marB="27432" anchor="ctr">
-                    <a:solidFill>
-                      <a:srgbClr val="FFFFFF"/>
-                    </a:solidFill>
-                  </a:tcPr>
-                </a:tc>
-              </a:tr>
-              <a:tr h="621792">
-                <a:tc>
-                  <a:txBody>
-                    <a:bodyPr wrap="square"/>
-                    <a:lstStyle/>
-                    <a:p>
-                      <a:r>
-                        <a:rPr sz="1400" b="1">
-                          <a:solidFill>
-                            <a:srgbClr val="222A33"/>
-                          </a:solidFill>
-                          <a:latin typeface="Calibri"/>
-                        </a:rPr>
-                        <a:t>Buys</a:t>
-                      </a:r>
-                    </a:p>
-                  </a:txBody>
-                  <a:tcPr marL="73152" marR="73152" marT="27432" marB="27432" anchor="ctr">
-                    <a:solidFill>
-                      <a:srgbClr val="EDF1F5"/>
-                    </a:solidFill>
-                  </a:tcPr>
-                </a:tc>
-                <a:tc>
-                  <a:txBody>
-                    <a:bodyPr wrap="square"/>
-                    <a:lstStyle/>
-                    <a:p>
-                      <a:r>
-                        <a:rPr sz="1400">
-                          <a:solidFill>
-                            <a:srgbClr val="222A33"/>
-                          </a:solidFill>
-                          <a:latin typeface="Calibri"/>
-                        </a:rPr>
-                        <a:t>stable schema, generic SQL, labels, v1/v2 pool</a:t>
-                      </a:r>
-                    </a:p>
-                  </a:txBody>
-                  <a:tcPr marL="73152" marR="73152" marT="27432" marB="27432" anchor="ctr">
-                    <a:solidFill>
-                      <a:srgbClr val="EDF1F5"/>
-                    </a:solidFill>
-                  </a:tcPr>
-                </a:tc>
-                <a:tc>
-                  <a:txBody>
-                    <a:bodyPr wrap="square"/>
-                    <a:lstStyle/>
-                    <a:p>
-                      <a:r>
-                        <a:rPr sz="1400">
-                          <a:solidFill>
-                            <a:srgbClr val="222A33"/>
-                          </a:solidFill>
-                          <a:latin typeface="Calibri"/>
-                        </a:rPr>
-                        <a:t>true missingness, governed access, marts, view library</a:t>
-                      </a:r>
-                    </a:p>
-                  </a:txBody>
-                  <a:tcPr marL="73152" marR="73152" marT="27432" marB="27432" anchor="ctr">
-                    <a:solidFill>
-                      <a:srgbClr val="EDF1F5"/>
-                    </a:solidFill>
-                  </a:tcPr>
-                </a:tc>
-              </a:tr>
-              <a:tr h="621792">
-                <a:tc>
-                  <a:txBody>
-                    <a:bodyPr wrap="square"/>
-                    <a:lstStyle/>
-                    <a:p>
-                      <a:r>
-                        <a:rPr sz="1400" b="1">
-                          <a:solidFill>
-                            <a:srgbClr val="222A33"/>
-                          </a:solidFill>
-                          <a:latin typeface="Calibri"/>
-                        </a:rPr>
-                        <a:t>Lift</a:t>
-                      </a:r>
-                    </a:p>
-                  </a:txBody>
-                  <a:tcPr marL="73152" marR="73152" marT="27432" marB="27432" anchor="ctr">
-                    <a:solidFill>
-                      <a:srgbClr val="FFFFFF"/>
-                    </a:solidFill>
-                  </a:tcPr>
-                </a:tc>
-                <a:tc>
-                  <a:txBody>
-                    <a:bodyPr wrap="square"/>
-                    <a:lstStyle/>
-                    <a:p>
-                      <a:r>
-                        <a:rPr sz="1400">
-                          <a:solidFill>
-                            <a:srgbClr val="222A33"/>
-                          </a:solidFill>
-                          <a:latin typeface="Calibri"/>
-                        </a:rPr>
-                        <a:t>low — reuses CleanConnect + dictionary</a:t>
-                      </a:r>
-                    </a:p>
-                  </a:txBody>
-                  <a:tcPr marL="73152" marR="73152" marT="27432" marB="27432" anchor="ctr">
-                    <a:solidFill>
-                      <a:srgbClr val="FFFFFF"/>
-                    </a:solidFill>
-                  </a:tcPr>
-                </a:tc>
-                <a:tc>
-                  <a:txBody>
-                    <a:bodyPr wrap="square"/>
-                    <a:lstStyle/>
-                    <a:p>
-                      <a:r>
-                        <a:rPr sz="1400">
-                          <a:solidFill>
-                            <a:srgbClr val="222A33"/>
-                          </a:solidFill>
-                          <a:latin typeface="Calibri"/>
-                        </a:rPr>
-                        <a:t>larger, phased — builds on Phase 1's fact</a:t>
-                      </a:r>
-                    </a:p>
-                  </a:txBody>
-                  <a:tcPr marL="73152" marR="73152" marT="27432" marB="27432" anchor="ctr">
-                    <a:solidFill>
-                      <a:srgbClr val="FFFFFF"/>
-                    </a:solidFill>
-                  </a:tcPr>
-                </a:tc>
-              </a:tr>
-              <a:tr h="621792">
-                <a:tc>
-                  <a:txBody>
-                    <a:bodyPr wrap="square"/>
-                    <a:lstStyle/>
-                    <a:p>
-                      <a:r>
-                        <a:rPr sz="1400" b="1">
-                          <a:solidFill>
-                            <a:srgbClr val="222A33"/>
-                          </a:solidFill>
-                          <a:latin typeface="Calibri"/>
-                        </a:rPr>
-                        <a:t>Release-ready</a:t>
-                      </a:r>
-                    </a:p>
-                  </a:txBody>
-                  <a:tcPr marL="73152" marR="73152" marT="27432" marB="27432" anchor="ctr">
-                    <a:solidFill>
-                      <a:srgbClr val="EDF1F5"/>
-                    </a:solidFill>
-                  </a:tcPr>
-                </a:tc>
-                <a:tc>
-                  <a:txBody>
-                    <a:bodyPr wrap="square"/>
-                    <a:lstStyle/>
-                    <a:p>
-                      <a:r>
-                        <a:rPr sz="1400">
-                          <a:solidFill>
-                            <a:srgbClr val="222A33"/>
-                          </a:solidFill>
-                          <a:latin typeface="Calibri"/>
-                        </a:rPr>
-                        <a:t>internal / analyst only</a:t>
-                      </a:r>
-                    </a:p>
-                  </a:txBody>
-                  <a:tcPr marL="73152" marR="73152" marT="27432" marB="27432" anchor="ctr">
-                    <a:solidFill>
-                      <a:srgbClr val="EDF1F5"/>
-                    </a:solidFill>
-                  </a:tcPr>
-                </a:tc>
-                <a:tc>
-                  <a:txBody>
-                    <a:bodyPr wrap="square"/>
-                    <a:lstStyle/>
-                    <a:p>
-                      <a:r>
-                        <a:rPr sz="1400">
-                          <a:solidFill>
-                            <a:srgbClr val="222A33"/>
-                          </a:solidFill>
-                          <a:latin typeface="Calibri"/>
-                        </a:rPr>
-                        <a:t>yes — external PR2 sharing</a:t>
-                      </a:r>
-                    </a:p>
-                  </a:txBody>
-                  <a:tcPr marL="73152" marR="73152" marT="27432" marB="27432" anchor="ctr">
-                    <a:solidFill>
-                      <a:srgbClr val="EDF1F5"/>
-                    </a:solidFill>
-                  </a:tcPr>
-                </a:tc>
-              </a:tr>
-            </a:tbl>
-          </a:graphicData>
-        </a:graphic>
-      </p:graphicFrame>
-      <p:sp>
-        <p:nvSpPr>
-          <p:cNvPr id="5" name="TextBox 4"/>
-          <p:cNvSpPr txBox="1"/>
-          <p:nvPr/>
-        </p:nvSpPr>
-        <p:spPr>
-          <a:xfrm>
-            <a:off x="548640" y="5120640"/>
-            <a:ext cx="11064240" cy="548640"/>
-          </a:xfrm>
-          <a:prstGeom prst="rect">
-            <a:avLst/>
-          </a:prstGeom>
-          <a:noFill/>
-        </p:spPr>
-        <p:txBody>
-          <a:bodyPr wrap="square">
-            <a:spAutoFit/>
-          </a:bodyPr>
-          <a:lstStyle/>
-          <a:p>
-            <a:pPr algn="l"/>
-            <a:r>
-              <a:rPr sz="1500" b="0" i="1">
-                <a:solidFill>
-                  <a:srgbClr val="5A636E"/>
-                </a:solidFill>
-                <a:latin typeface="Calibri"/>
-              </a:rPr>
-              <a:t>Same responses fact both phases — Phase 1 is a down payment, not throwaway work.</a:t>
             </a:r>
           </a:p>
         </p:txBody>

</xml_diff>